<commit_message>
docs: single-page high-level architecture diagram
Five layers on one landscape page: clients, API, security pipeline,
intelligence, data and audit. Carries the real numbers rather than
generic boxes — risk weights, band thresholds, replica count — so it can
be read alongside the decision-logic section rather than restating it.

Language names are written in Latin because the embedded font has no
Devanagari or Gurmukhi glyphs; the native scripts rendered as empty
boxes.
</commit_message>
<xml_diff>
--- a/demo/SecureWealth_Twin_Video_Closing_Slides.pptx
+++ b/demo/SecureWealth_Twin_Video_Closing_Slides.pptx
@@ -1,22 +1,22 @@
 
 <file path=ppt/presentation.xml><?xml version="1.0" encoding="utf-8"?>
-<p:presentation xmlns:a="http://schemas.openxmlformats.org/drawingml/2006/main" xmlns:r="http://schemas.openxmlformats.org/officeDocument/2006/relationships" xmlns:p="http://schemas.openxmlformats.org/presentationml/2006/main" saveSubsetFonts="1" autoCompressPictures="0">
+<p:presentation xmlns:a="http://schemas.openxmlformats.org/drawingml/2006/main" xmlns:r="http://schemas.openxmlformats.org/officeDocument/2006/relationships" xmlns:p="http://schemas.openxmlformats.org/presentationml/2006/main" xmlns:m="http://schemas.openxmlformats.org/officeDocument/2006/math" xmlns:w="http://schemas.openxmlformats.org/wordprocessingml/2006/main" autoCompressPictures="0" saveSubsetFonts="1">
   <p:sldMasterIdLst>
     <p:sldMasterId id="2147483648" r:id="rId1"/>
   </p:sldMasterIdLst>
+  <p:notesMasterIdLst>
+    <p:notesMasterId r:id="rId6"/>
+  </p:notesMasterIdLst>
   <p:sldIdLst>
-    <p:sldId id="256" r:id="rId2"/>
-    <p:sldId id="257" r:id="rId3"/>
-    <p:sldId id="258" r:id="rId4"/>
+    <p:sldId id="256" r:id="rId3"/>
+    <p:sldId id="257" r:id="rId4"/>
+    <p:sldId id="258" r:id="rId5"/>
   </p:sldIdLst>
-  <p:notesMasterIdLst>
-    <p:notesMasterId r:id="rId5"/>
-  </p:notesMasterIdLst>
   <p:sldSz cx="12192000" cy="6858000"/>
   <p:notesSz cx="6858000" cy="12192000"/>
   <p:defaultTextStyle>
-    <a:lvl1pPr marL="0" algn="l" defTabSz="914400" rtl="0" eaLnBrk="1" latinLnBrk="0" hangingPunct="1">
-      <a:defRPr sz="1800" kern="1200">
+    <a:lvl1pPr marL="0" algn="l" defTabSz="914400" rtl="0">
+      <a:defRPr sz="1800">
         <a:solidFill>
           <a:schemeClr val="tx1"/>
         </a:solidFill>
@@ -25,8 +25,8 @@
         <a:cs typeface="+mn-cs"/>
       </a:defRPr>
     </a:lvl1pPr>
-    <a:lvl2pPr marL="457200" algn="l" defTabSz="914400" rtl="0" eaLnBrk="1" latinLnBrk="0" hangingPunct="1">
-      <a:defRPr sz="1800" kern="1200">
+    <a:lvl2pPr marL="457200" algn="l" defTabSz="914400" rtl="0">
+      <a:defRPr sz="1800">
         <a:solidFill>
           <a:schemeClr val="tx1"/>
         </a:solidFill>
@@ -35,8 +35,8 @@
         <a:cs typeface="+mn-cs"/>
       </a:defRPr>
     </a:lvl2pPr>
-    <a:lvl3pPr marL="914400" algn="l" defTabSz="914400" rtl="0" eaLnBrk="1" latinLnBrk="0" hangingPunct="1">
-      <a:defRPr sz="1800" kern="1200">
+    <a:lvl3pPr marL="914400" algn="l" defTabSz="914400" rtl="0">
+      <a:defRPr sz="1800">
         <a:solidFill>
           <a:schemeClr val="tx1"/>
         </a:solidFill>
@@ -45,8 +45,8 @@
         <a:cs typeface="+mn-cs"/>
       </a:defRPr>
     </a:lvl3pPr>
-    <a:lvl4pPr marL="1371600" algn="l" defTabSz="914400" rtl="0" eaLnBrk="1" latinLnBrk="0" hangingPunct="1">
-      <a:defRPr sz="1800" kern="1200">
+    <a:lvl4pPr marL="1371600" algn="l" defTabSz="914400" rtl="0">
+      <a:defRPr sz="1800">
         <a:solidFill>
           <a:schemeClr val="tx1"/>
         </a:solidFill>
@@ -55,8 +55,8 @@
         <a:cs typeface="+mn-cs"/>
       </a:defRPr>
     </a:lvl4pPr>
-    <a:lvl5pPr marL="1828800" algn="l" defTabSz="914400" rtl="0" eaLnBrk="1" latinLnBrk="0" hangingPunct="1">
-      <a:defRPr sz="1800" kern="1200">
+    <a:lvl5pPr marL="1828800" algn="l" defTabSz="914400" rtl="0">
+      <a:defRPr sz="1800">
         <a:solidFill>
           <a:schemeClr val="tx1"/>
         </a:solidFill>
@@ -65,8 +65,8 @@
         <a:cs typeface="+mn-cs"/>
       </a:defRPr>
     </a:lvl5pPr>
-    <a:lvl6pPr marL="2286000" algn="l" defTabSz="914400" rtl="0" eaLnBrk="1" latinLnBrk="0" hangingPunct="1">
-      <a:defRPr sz="1800" kern="1200">
+    <a:lvl6pPr marL="2286000" algn="l" defTabSz="914400" rtl="0">
+      <a:defRPr sz="1800">
         <a:solidFill>
           <a:schemeClr val="tx1"/>
         </a:solidFill>
@@ -75,8 +75,8 @@
         <a:cs typeface="+mn-cs"/>
       </a:defRPr>
     </a:lvl6pPr>
-    <a:lvl7pPr marL="2743200" algn="l" defTabSz="914400" rtl="0" eaLnBrk="1" latinLnBrk="0" hangingPunct="1">
-      <a:defRPr sz="1800" kern="1200">
+    <a:lvl7pPr marL="2743200" algn="l" defTabSz="914400" rtl="0">
+      <a:defRPr sz="1800">
         <a:solidFill>
           <a:schemeClr val="tx1"/>
         </a:solidFill>
@@ -85,8 +85,8 @@
         <a:cs typeface="+mn-cs"/>
       </a:defRPr>
     </a:lvl7pPr>
-    <a:lvl8pPr marL="3200400" algn="l" defTabSz="914400" rtl="0" eaLnBrk="1" latinLnBrk="0" hangingPunct="1">
-      <a:defRPr sz="1800" kern="1200">
+    <a:lvl8pPr marL="3200400" algn="l" defTabSz="914400" rtl="0">
+      <a:defRPr sz="1800">
         <a:solidFill>
           <a:schemeClr val="tx1"/>
         </a:solidFill>
@@ -95,8 +95,8 @@
         <a:cs typeface="+mn-cs"/>
       </a:defRPr>
     </a:lvl8pPr>
-    <a:lvl9pPr marL="3657600" algn="l" defTabSz="914400" rtl="0" eaLnBrk="1" latinLnBrk="0" hangingPunct="1">
-      <a:defRPr sz="1800" kern="1200">
+    <a:lvl9pPr marL="3657600" algn="l" defTabSz="914400" rtl="0">
+      <a:defRPr sz="1800">
         <a:solidFill>
           <a:schemeClr val="tx1"/>
         </a:solidFill>
@@ -111,7 +111,7 @@
 
 <file path=ppt/notesMasters/notesMaster1.xml><?xml version="1.0" encoding="utf-8"?>
 <p:notesMaster xmlns:a="http://schemas.openxmlformats.org/drawingml/2006/main" xmlns:r="http://schemas.openxmlformats.org/officeDocument/2006/relationships" xmlns:p="http://schemas.openxmlformats.org/presentationml/2006/main">
-  <p:cSld>
+  <p:cSld name="">
     <p:bg>
       <p:bgRef idx="1001">
         <a:schemeClr val="bg1"/>
@@ -123,7 +123,7 @@
         <p:cNvGrpSpPr/>
         <p:nvPr/>
       </p:nvGrpSpPr>
-      <p:grpSpPr>
+      <p:grpSpPr bwMode="auto">
         <a:xfrm>
           <a:off x="0" y="0"/>
           <a:ext cx="0" cy="0"/>
@@ -133,7 +133,7 @@
       </p:grpSpPr>
       <p:sp>
         <p:nvSpPr>
-          <p:cNvPr id="2" name="Header Placeholder 1"/>
+          <p:cNvPr id="229564636" name="Header Placeholder 1"/>
           <p:cNvSpPr>
             <a:spLocks noGrp="1"/>
           </p:cNvSpPr>
@@ -141,7 +141,7 @@
             <p:ph type="hdr" sz="quarter"/>
           </p:nvPr>
         </p:nvSpPr>
-        <p:spPr>
+        <p:spPr bwMode="auto">
           <a:xfrm>
             <a:off x="0" y="0"/>
             <a:ext cx="2971800" cy="458788"/>
@@ -158,13 +158,16 @@
             </a:lvl1pPr>
           </a:lstStyle>
           <a:p>
+            <a:pPr>
+              <a:defRPr/>
+            </a:pPr>
             <a:endParaRPr lang="en-US"/>
           </a:p>
         </p:txBody>
       </p:sp>
       <p:sp>
         <p:nvSpPr>
-          <p:cNvPr id="3" name="Date Placeholder 2"/>
+          <p:cNvPr id="1942019882" name="Date Placeholder 2"/>
           <p:cNvSpPr>
             <a:spLocks noGrp="1"/>
           </p:cNvSpPr>
@@ -172,7 +175,7 @@
             <p:ph type="dt" idx="1"/>
           </p:nvPr>
         </p:nvSpPr>
-        <p:spPr>
+        <p:spPr bwMode="auto">
           <a:xfrm>
             <a:off x="3884613" y="0"/>
             <a:ext cx="2971800" cy="458788"/>
@@ -189,6 +192,9 @@
             </a:lvl1pPr>
           </a:lstStyle>
           <a:p>
+            <a:pPr>
+              <a:defRPr/>
+            </a:pPr>
             <a:fld id="{5282F153-3F37-0F45-9E97-73ACFA13230C}" type="datetimeFigureOut">
               <a:rPr lang="en-US"/>
               <a:t>7/23/19</a:t>
@@ -199,15 +205,15 @@
       </p:sp>
       <p:sp>
         <p:nvSpPr>
-          <p:cNvPr id="4" name="Slide Image Placeholder 3"/>
+          <p:cNvPr id="1104850460" name="Slide Image Placeholder 3"/>
           <p:cNvSpPr>
-            <a:spLocks noGrp="1" noRot="1" noChangeAspect="1"/>
+            <a:spLocks noChangeAspect="1" noGrp="1" noRot="1"/>
           </p:cNvSpPr>
           <p:nvPr>
             <p:ph type="sldImg" idx="2"/>
           </p:nvPr>
         </p:nvSpPr>
-        <p:spPr>
+        <p:spPr bwMode="auto">
           <a:xfrm>
             <a:off x="685800" y="1143000"/>
             <a:ext cx="5486400" cy="3086100"/>
@@ -226,13 +232,16 @@
           <a:bodyPr vert="horz" lIns="91440" tIns="45720" rIns="91440" bIns="45720" rtlCol="0" anchor="ctr"/>
           <a:lstStyle/>
           <a:p>
+            <a:pPr>
+              <a:defRPr/>
+            </a:pPr>
             <a:endParaRPr lang="en-US"/>
           </a:p>
         </p:txBody>
       </p:sp>
       <p:sp>
         <p:nvSpPr>
-          <p:cNvPr id="5" name="Notes Placeholder 4"/>
+          <p:cNvPr id="183855242" name="Notes Placeholder 4"/>
           <p:cNvSpPr>
             <a:spLocks noGrp="1"/>
           </p:cNvSpPr>
@@ -240,7 +249,7 @@
             <p:ph type="body" sz="quarter" idx="3"/>
           </p:nvPr>
         </p:nvSpPr>
-        <p:spPr>
+        <p:spPr bwMode="auto">
           <a:xfrm>
             <a:off x="685800" y="4400550"/>
             <a:ext cx="5486400" cy="3600450"/>
@@ -253,45 +262,60 @@
           <a:bodyPr vert="horz" lIns="91440" tIns="45720" rIns="91440" bIns="45720" rtlCol="0"/>
           <a:lstStyle/>
           <a:p>
-            <a:pPr lvl="0"/>
+            <a:pPr lvl="0">
+              <a:defRPr/>
+            </a:pPr>
             <a:r>
               <a:rPr lang="en-US"/>
               <a:t>Click to edit Master text styles</a:t>
             </a:r>
-          </a:p>
-          <a:p>
-            <a:pPr lvl="1"/>
+            <a:endParaRPr/>
+          </a:p>
+          <a:p>
+            <a:pPr lvl="1">
+              <a:defRPr/>
+            </a:pPr>
             <a:r>
               <a:rPr lang="en-US"/>
               <a:t>Second level</a:t>
             </a:r>
-          </a:p>
-          <a:p>
-            <a:pPr lvl="2"/>
+            <a:endParaRPr/>
+          </a:p>
+          <a:p>
+            <a:pPr lvl="2">
+              <a:defRPr/>
+            </a:pPr>
             <a:r>
               <a:rPr lang="en-US"/>
               <a:t>Third level</a:t>
             </a:r>
-          </a:p>
-          <a:p>
-            <a:pPr lvl="3"/>
+            <a:endParaRPr/>
+          </a:p>
+          <a:p>
+            <a:pPr lvl="3">
+              <a:defRPr/>
+            </a:pPr>
             <a:r>
               <a:rPr lang="en-US"/>
               <a:t>Fourth level</a:t>
             </a:r>
-          </a:p>
-          <a:p>
-            <a:pPr lvl="4"/>
+            <a:endParaRPr/>
+          </a:p>
+          <a:p>
+            <a:pPr lvl="4">
+              <a:defRPr/>
+            </a:pPr>
             <a:r>
               <a:rPr lang="en-US"/>
               <a:t>Fifth level</a:t>
             </a:r>
-          </a:p>
-        </p:txBody>
-      </p:sp>
-      <p:sp>
-        <p:nvSpPr>
-          <p:cNvPr id="6" name="Footer Placeholder 5"/>
+            <a:endParaRPr/>
+          </a:p>
+        </p:txBody>
+      </p:sp>
+      <p:sp>
+        <p:nvSpPr>
+          <p:cNvPr id="1470722050" name="Footer Placeholder 5"/>
           <p:cNvSpPr>
             <a:spLocks noGrp="1"/>
           </p:cNvSpPr>
@@ -299,7 +323,7 @@
             <p:ph type="ftr" sz="quarter" idx="4"/>
           </p:nvPr>
         </p:nvSpPr>
-        <p:spPr>
+        <p:spPr bwMode="auto">
           <a:xfrm>
             <a:off x="0" y="8685213"/>
             <a:ext cx="2971800" cy="458787"/>
@@ -316,13 +340,16 @@
             </a:lvl1pPr>
           </a:lstStyle>
           <a:p>
+            <a:pPr>
+              <a:defRPr/>
+            </a:pPr>
             <a:endParaRPr lang="en-US"/>
           </a:p>
         </p:txBody>
       </p:sp>
       <p:sp>
         <p:nvSpPr>
-          <p:cNvPr id="7" name="Slide Number Placeholder 6"/>
+          <p:cNvPr id="394841790" name="Slide Number Placeholder 6"/>
           <p:cNvSpPr>
             <a:spLocks noGrp="1"/>
           </p:cNvSpPr>
@@ -330,7 +357,7 @@
             <p:ph type="sldNum" sz="quarter" idx="5"/>
           </p:nvPr>
         </p:nvSpPr>
-        <p:spPr>
+        <p:spPr bwMode="auto">
           <a:xfrm>
             <a:off x="3884613" y="8685213"/>
             <a:ext cx="2971800" cy="458787"/>
@@ -347,6 +374,9 @@
             </a:lvl1pPr>
           </a:lstStyle>
           <a:p>
+            <a:pPr>
+              <a:defRPr/>
+            </a:pPr>
             <a:fld id="{CE5E9CC1-C706-0F49-92D6-E571CC5EEA8F}" type="slidenum">
               <a:rPr lang="en-US"/>
               <a:t>‹#›</a:t>
@@ -356,16 +386,11 @@
         </p:txBody>
       </p:sp>
     </p:spTree>
-    <p:extLst>
-      <p:ext uri="{BB962C8B-B14F-4D97-AF65-F5344CB8AC3E}">
-        <p14:creationId xmlns:p14="http://schemas.microsoft.com/office/powerpoint/2010/main" val="1024086991"/>
-      </p:ext>
-    </p:extLst>
   </p:cSld>
   <p:clrMap bg1="lt1" tx1="dk1" bg2="lt2" tx2="dk2" accent1="accent1" accent2="accent2" accent3="accent3" accent4="accent4" accent5="accent5" accent6="accent6" hlink="hlink" folHlink="folHlink"/>
   <p:notesStyle>
-    <a:lvl1pPr marL="0" algn="l" defTabSz="914400" rtl="0" eaLnBrk="1" latinLnBrk="0" hangingPunct="1">
-      <a:defRPr sz="1200" kern="1200">
+    <a:lvl1pPr marL="0" algn="l" defTabSz="914400" rtl="0">
+      <a:defRPr sz="1200">
         <a:solidFill>
           <a:schemeClr val="tx1"/>
         </a:solidFill>
@@ -374,8 +399,8 @@
         <a:cs typeface="+mn-cs"/>
       </a:defRPr>
     </a:lvl1pPr>
-    <a:lvl2pPr marL="457200" algn="l" defTabSz="914400" rtl="0" eaLnBrk="1" latinLnBrk="0" hangingPunct="1">
-      <a:defRPr sz="1200" kern="1200">
+    <a:lvl2pPr marL="457200" algn="l" defTabSz="914400" rtl="0">
+      <a:defRPr sz="1200">
         <a:solidFill>
           <a:schemeClr val="tx1"/>
         </a:solidFill>
@@ -384,8 +409,8 @@
         <a:cs typeface="+mn-cs"/>
       </a:defRPr>
     </a:lvl2pPr>
-    <a:lvl3pPr marL="914400" algn="l" defTabSz="914400" rtl="0" eaLnBrk="1" latinLnBrk="0" hangingPunct="1">
-      <a:defRPr sz="1200" kern="1200">
+    <a:lvl3pPr marL="914400" algn="l" defTabSz="914400" rtl="0">
+      <a:defRPr sz="1200">
         <a:solidFill>
           <a:schemeClr val="tx1"/>
         </a:solidFill>
@@ -394,8 +419,8 @@
         <a:cs typeface="+mn-cs"/>
       </a:defRPr>
     </a:lvl3pPr>
-    <a:lvl4pPr marL="1371600" algn="l" defTabSz="914400" rtl="0" eaLnBrk="1" latinLnBrk="0" hangingPunct="1">
-      <a:defRPr sz="1200" kern="1200">
+    <a:lvl4pPr marL="1371600" algn="l" defTabSz="914400" rtl="0">
+      <a:defRPr sz="1200">
         <a:solidFill>
           <a:schemeClr val="tx1"/>
         </a:solidFill>
@@ -404,8 +429,8 @@
         <a:cs typeface="+mn-cs"/>
       </a:defRPr>
     </a:lvl4pPr>
-    <a:lvl5pPr marL="1828800" algn="l" defTabSz="914400" rtl="0" eaLnBrk="1" latinLnBrk="0" hangingPunct="1">
-      <a:defRPr sz="1200" kern="1200">
+    <a:lvl5pPr marL="1828800" algn="l" defTabSz="914400" rtl="0">
+      <a:defRPr sz="1200">
         <a:solidFill>
           <a:schemeClr val="tx1"/>
         </a:solidFill>
@@ -414,8 +439,8 @@
         <a:cs typeface="+mn-cs"/>
       </a:defRPr>
     </a:lvl5pPr>
-    <a:lvl6pPr marL="2286000" algn="l" defTabSz="914400" rtl="0" eaLnBrk="1" latinLnBrk="0" hangingPunct="1">
-      <a:defRPr sz="1200" kern="1200">
+    <a:lvl6pPr marL="2286000" algn="l" defTabSz="914400" rtl="0">
+      <a:defRPr sz="1200">
         <a:solidFill>
           <a:schemeClr val="tx1"/>
         </a:solidFill>
@@ -424,8 +449,8 @@
         <a:cs typeface="+mn-cs"/>
       </a:defRPr>
     </a:lvl6pPr>
-    <a:lvl7pPr marL="2743200" algn="l" defTabSz="914400" rtl="0" eaLnBrk="1" latinLnBrk="0" hangingPunct="1">
-      <a:defRPr sz="1200" kern="1200">
+    <a:lvl7pPr marL="2743200" algn="l" defTabSz="914400" rtl="0">
+      <a:defRPr sz="1200">
         <a:solidFill>
           <a:schemeClr val="tx1"/>
         </a:solidFill>
@@ -434,8 +459,8 @@
         <a:cs typeface="+mn-cs"/>
       </a:defRPr>
     </a:lvl7pPr>
-    <a:lvl8pPr marL="3200400" algn="l" defTabSz="914400" rtl="0" eaLnBrk="1" latinLnBrk="0" hangingPunct="1">
-      <a:defRPr sz="1200" kern="1200">
+    <a:lvl8pPr marL="3200400" algn="l" defTabSz="914400" rtl="0">
+      <a:defRPr sz="1200">
         <a:solidFill>
           <a:schemeClr val="tx1"/>
         </a:solidFill>
@@ -444,8 +469,8 @@
         <a:cs typeface="+mn-cs"/>
       </a:defRPr>
     </a:lvl8pPr>
-    <a:lvl9pPr marL="3657600" algn="l" defTabSz="914400" rtl="0" eaLnBrk="1" latinLnBrk="0" hangingPunct="1">
-      <a:defRPr sz="1200" kern="1200">
+    <a:lvl9pPr marL="3657600" algn="l" defTabSz="914400" rtl="0">
+      <a:defRPr sz="1200">
         <a:solidFill>
           <a:schemeClr val="tx1"/>
         </a:solidFill>
@@ -459,15 +484,15 @@
 </file>
 
 <file path=ppt/notesSlides/notesSlide1.xml><?xml version="1.0" encoding="utf-8"?>
-<p:notes xmlns:a="http://schemas.openxmlformats.org/drawingml/2006/main" xmlns:r="http://schemas.openxmlformats.org/officeDocument/2006/relationships" xmlns:p="http://schemas.openxmlformats.org/presentationml/2006/main">
-  <p:cSld>
+<p:notes xmlns:a="http://schemas.openxmlformats.org/drawingml/2006/main" xmlns:r="http://schemas.openxmlformats.org/officeDocument/2006/relationships" xmlns:p="http://schemas.openxmlformats.org/presentationml/2006/main" xmlns:m="http://schemas.openxmlformats.org/officeDocument/2006/math" xmlns:w="http://schemas.openxmlformats.org/wordprocessingml/2006/main">
+  <p:cSld name="">
     <p:spTree>
       <p:nvGrpSpPr>
         <p:cNvPr id="1" name=""/>
         <p:cNvGrpSpPr/>
         <p:nvPr/>
       </p:nvGrpSpPr>
-      <p:grpSpPr>
+      <p:grpSpPr bwMode="auto">
         <a:xfrm>
           <a:off x="0" y="0"/>
           <a:ext cx="0" cy="0"/>
@@ -477,19 +502,19 @@
       </p:grpSpPr>
       <p:sp>
         <p:nvSpPr>
-          <p:cNvPr id="2" name="Slide Image Placeholder 1"/>
+          <p:cNvPr id="104180293" name="Slide Image Placeholder 1"/>
           <p:cNvSpPr>
-            <a:spLocks noGrp="1" noRot="1" noChangeAspect="1"/>
+            <a:spLocks noChangeAspect="1" noGrp="1" noRot="1"/>
           </p:cNvSpPr>
           <p:nvPr>
             <p:ph type="sldImg"/>
           </p:nvPr>
         </p:nvSpPr>
-        <p:spPr/>
-      </p:sp>
-      <p:sp>
-        <p:nvSpPr>
-          <p:cNvPr id="3" name="Notes Placeholder 2"/>
+        <p:spPr bwMode="auto"/>
+      </p:sp>
+      <p:sp>
+        <p:nvSpPr>
+          <p:cNvPr id="94088049" name="Notes Placeholder 2"/>
           <p:cNvSpPr>
             <a:spLocks noGrp="1"/>
           </p:cNvSpPr>
@@ -497,22 +522,25 @@
             <p:ph type="body" idx="1"/>
           </p:nvPr>
         </p:nvSpPr>
-        <p:spPr/>
+        <p:spPr bwMode="auto"/>
         <p:txBody>
           <a:bodyPr/>
           <a:lstStyle/>
           <a:p>
-            <a:r>
-              <a:rPr lang="en-US" dirty="0"/>
+            <a:pPr>
+              <a:defRPr/>
+            </a:pPr>
+            <a:r>
+              <a:rPr lang="en-US"/>
               <a:t>Hold on this slide for the first sentence of the closing voice-over.</a:t>
             </a:r>
-            <a:endParaRPr lang="en-US" dirty="0"/>
-          </a:p>
-        </p:txBody>
-      </p:sp>
-      <p:sp>
-        <p:nvSpPr>
-          <p:cNvPr id="4" name="Slide Number Placeholder 3"/>
+            <a:endParaRPr lang="en-US"/>
+          </a:p>
+        </p:txBody>
+      </p:sp>
+      <p:sp>
+        <p:nvSpPr>
+          <p:cNvPr id="1067367323" name="Slide Number Placeholder 3"/>
           <p:cNvSpPr>
             <a:spLocks noGrp="1"/>
           </p:cNvSpPr>
@@ -520,11 +548,14 @@
             <p:ph type="sldNum" sz="quarter" idx="10"/>
           </p:nvPr>
         </p:nvSpPr>
-        <p:spPr/>
+        <p:spPr bwMode="auto"/>
         <p:txBody>
           <a:bodyPr/>
           <a:lstStyle/>
           <a:p>
+            <a:pPr>
+              <a:defRPr/>
+            </a:pPr>
             <a:fld id="{F7021451-1387-4CA6-816F-3879F97B5CBC}" type="slidenum">
               <a:rPr lang="en-US"/>
               <a:t>1</a:t>
@@ -534,11 +565,6 @@
         </p:txBody>
       </p:sp>
     </p:spTree>
-    <p:extLst>
-      <p:ext uri="{BB962C8B-B14F-4D97-AF65-F5344CB8AC3E}">
-        <p14:creationId xmlns:p14="http://schemas.microsoft.com/office/powerpoint/2010/main" val="1024086991"/>
-      </p:ext>
-    </p:extLst>
   </p:cSld>
   <p:clrMapOvr>
     <a:masterClrMapping/>
@@ -547,15 +573,15 @@
 </file>
 
 <file path=ppt/notesSlides/notesSlide2.xml><?xml version="1.0" encoding="utf-8"?>
-<p:notes xmlns:a="http://schemas.openxmlformats.org/drawingml/2006/main" xmlns:r="http://schemas.openxmlformats.org/officeDocument/2006/relationships" xmlns:p="http://schemas.openxmlformats.org/presentationml/2006/main">
-  <p:cSld>
+<p:notes xmlns:a="http://schemas.openxmlformats.org/drawingml/2006/main" xmlns:r="http://schemas.openxmlformats.org/officeDocument/2006/relationships" xmlns:p="http://schemas.openxmlformats.org/presentationml/2006/main" xmlns:m="http://schemas.openxmlformats.org/officeDocument/2006/math" xmlns:w="http://schemas.openxmlformats.org/wordprocessingml/2006/main">
+  <p:cSld name="">
     <p:spTree>
       <p:nvGrpSpPr>
         <p:cNvPr id="1" name=""/>
         <p:cNvGrpSpPr/>
         <p:nvPr/>
       </p:nvGrpSpPr>
-      <p:grpSpPr>
+      <p:grpSpPr bwMode="auto">
         <a:xfrm>
           <a:off x="0" y="0"/>
           <a:ext cx="0" cy="0"/>
@@ -565,19 +591,19 @@
       </p:grpSpPr>
       <p:sp>
         <p:nvSpPr>
-          <p:cNvPr id="2" name="Slide Image Placeholder 1"/>
+          <p:cNvPr id="621595254" name="Slide Image Placeholder 1"/>
           <p:cNvSpPr>
-            <a:spLocks noGrp="1" noRot="1" noChangeAspect="1"/>
+            <a:spLocks noChangeAspect="1" noGrp="1" noRot="1"/>
           </p:cNvSpPr>
           <p:nvPr>
             <p:ph type="sldImg"/>
           </p:nvPr>
         </p:nvSpPr>
-        <p:spPr/>
-      </p:sp>
-      <p:sp>
-        <p:nvSpPr>
-          <p:cNvPr id="3" name="Notes Placeholder 2"/>
+        <p:spPr bwMode="auto"/>
+      </p:sp>
+      <p:sp>
+        <p:nvSpPr>
+          <p:cNvPr id="141318328" name="Notes Placeholder 2"/>
           <p:cNvSpPr>
             <a:spLocks noGrp="1"/>
           </p:cNvSpPr>
@@ -585,22 +611,25 @@
             <p:ph type="body" idx="1"/>
           </p:nvPr>
         </p:nvSpPr>
-        <p:spPr/>
+        <p:spPr bwMode="auto"/>
         <p:txBody>
           <a:bodyPr/>
           <a:lstStyle/>
           <a:p>
-            <a:r>
-              <a:rPr lang="en-US" dirty="0"/>
+            <a:pPr>
+              <a:defRPr/>
+            </a:pPr>
+            <a:r>
+              <a:rPr lang="en-US"/>
               <a:t>Hold on this slide for the second sentence of the closing voice-over.</a:t>
             </a:r>
-            <a:endParaRPr lang="en-US" dirty="0"/>
-          </a:p>
-        </p:txBody>
-      </p:sp>
-      <p:sp>
-        <p:nvSpPr>
-          <p:cNvPr id="4" name="Slide Number Placeholder 3"/>
+            <a:endParaRPr lang="en-US"/>
+          </a:p>
+        </p:txBody>
+      </p:sp>
+      <p:sp>
+        <p:nvSpPr>
+          <p:cNvPr id="1696641321" name="Slide Number Placeholder 3"/>
           <p:cNvSpPr>
             <a:spLocks noGrp="1"/>
           </p:cNvSpPr>
@@ -608,11 +637,14 @@
             <p:ph type="sldNum" sz="quarter" idx="10"/>
           </p:nvPr>
         </p:nvSpPr>
-        <p:spPr/>
+        <p:spPr bwMode="auto"/>
         <p:txBody>
           <a:bodyPr/>
           <a:lstStyle/>
           <a:p>
+            <a:pPr>
+              <a:defRPr/>
+            </a:pPr>
             <a:fld id="{F7021451-1387-4CA6-816F-3879F97B5CBC}" type="slidenum">
               <a:rPr lang="en-US"/>
               <a:t>2</a:t>
@@ -622,11 +654,6 @@
         </p:txBody>
       </p:sp>
     </p:spTree>
-    <p:extLst>
-      <p:ext uri="{BB962C8B-B14F-4D97-AF65-F5344CB8AC3E}">
-        <p14:creationId xmlns:p14="http://schemas.microsoft.com/office/powerpoint/2010/main" val="1024086991"/>
-      </p:ext>
-    </p:extLst>
   </p:cSld>
   <p:clrMapOvr>
     <a:masterClrMapping/>
@@ -635,15 +662,15 @@
 </file>
 
 <file path=ppt/notesSlides/notesSlide3.xml><?xml version="1.0" encoding="utf-8"?>
-<p:notes xmlns:a="http://schemas.openxmlformats.org/drawingml/2006/main" xmlns:r="http://schemas.openxmlformats.org/officeDocument/2006/relationships" xmlns:p="http://schemas.openxmlformats.org/presentationml/2006/main">
-  <p:cSld>
+<p:notes xmlns:a="http://schemas.openxmlformats.org/drawingml/2006/main" xmlns:r="http://schemas.openxmlformats.org/officeDocument/2006/relationships" xmlns:p="http://schemas.openxmlformats.org/presentationml/2006/main" xmlns:m="http://schemas.openxmlformats.org/officeDocument/2006/math" xmlns:w="http://schemas.openxmlformats.org/wordprocessingml/2006/main">
+  <p:cSld name="">
     <p:spTree>
       <p:nvGrpSpPr>
         <p:cNvPr id="1" name=""/>
         <p:cNvGrpSpPr/>
         <p:nvPr/>
       </p:nvGrpSpPr>
-      <p:grpSpPr>
+      <p:grpSpPr bwMode="auto">
         <a:xfrm>
           <a:off x="0" y="0"/>
           <a:ext cx="0" cy="0"/>
@@ -653,19 +680,19 @@
       </p:grpSpPr>
       <p:sp>
         <p:nvSpPr>
-          <p:cNvPr id="2" name="Slide Image Placeholder 1"/>
+          <p:cNvPr id="1956426188" name="Slide Image Placeholder 1"/>
           <p:cNvSpPr>
-            <a:spLocks noGrp="1" noRot="1" noChangeAspect="1"/>
+            <a:spLocks noChangeAspect="1" noGrp="1" noRot="1"/>
           </p:cNvSpPr>
           <p:nvPr>
             <p:ph type="sldImg"/>
           </p:nvPr>
         </p:nvSpPr>
-        <p:spPr/>
-      </p:sp>
-      <p:sp>
-        <p:nvSpPr>
-          <p:cNvPr id="3" name="Notes Placeholder 2"/>
+        <p:spPr bwMode="auto"/>
+      </p:sp>
+      <p:sp>
+        <p:nvSpPr>
+          <p:cNvPr id="736937255" name="Notes Placeholder 2"/>
           <p:cNvSpPr>
             <a:spLocks noGrp="1"/>
           </p:cNvSpPr>
@@ -673,22 +700,25 @@
             <p:ph type="body" idx="1"/>
           </p:nvPr>
         </p:nvSpPr>
-        <p:spPr/>
+        <p:spPr bwMode="auto"/>
         <p:txBody>
           <a:bodyPr/>
           <a:lstStyle/>
           <a:p>
-            <a:r>
-              <a:rPr lang="en-US" dirty="0"/>
+            <a:pPr>
+              <a:defRPr/>
+            </a:pPr>
+            <a:r>
+              <a:rPr lang="en-US"/>
               <a:t>Final slide. Hold for two seconds of silence after "Thank you" before cutting.</a:t>
             </a:r>
-            <a:endParaRPr lang="en-US" dirty="0"/>
-          </a:p>
-        </p:txBody>
-      </p:sp>
-      <p:sp>
-        <p:nvSpPr>
-          <p:cNvPr id="4" name="Slide Number Placeholder 3"/>
+            <a:endParaRPr lang="en-US"/>
+          </a:p>
+        </p:txBody>
+      </p:sp>
+      <p:sp>
+        <p:nvSpPr>
+          <p:cNvPr id="1237059258" name="Slide Number Placeholder 3"/>
           <p:cNvSpPr>
             <a:spLocks noGrp="1"/>
           </p:cNvSpPr>
@@ -696,11 +726,14 @@
             <p:ph type="sldNum" sz="quarter" idx="10"/>
           </p:nvPr>
         </p:nvSpPr>
-        <p:spPr/>
+        <p:spPr bwMode="auto"/>
         <p:txBody>
           <a:bodyPr/>
           <a:lstStyle/>
           <a:p>
+            <a:pPr>
+              <a:defRPr/>
+            </a:pPr>
             <a:fld id="{F7021451-1387-4CA6-816F-3879F97B5CBC}" type="slidenum">
               <a:rPr lang="en-US"/>
               <a:t>3</a:t>
@@ -710,11 +743,6 @@
         </p:txBody>
       </p:sp>
     </p:spTree>
-    <p:extLst>
-      <p:ext uri="{BB962C8B-B14F-4D97-AF65-F5344CB8AC3E}">
-        <p14:creationId xmlns:p14="http://schemas.microsoft.com/office/powerpoint/2010/main" val="1024086991"/>
-      </p:ext>
-    </p:extLst>
   </p:cSld>
   <p:clrMapOvr>
     <a:masterClrMapping/>
@@ -723,7 +751,7 @@
 </file>
 
 <file path=ppt/slideLayouts/slideLayout1.xml><?xml version="1.0" encoding="utf-8"?>
-<p:sldLayout xmlns:a="http://schemas.openxmlformats.org/drawingml/2006/main" xmlns:r="http://schemas.openxmlformats.org/officeDocument/2006/relationships" xmlns:p="http://schemas.openxmlformats.org/presentationml/2006/main" preserve="1">
+<p:sldLayout xmlns:a="http://schemas.openxmlformats.org/drawingml/2006/main" xmlns:r="http://schemas.openxmlformats.org/officeDocument/2006/relationships" xmlns:p="http://schemas.openxmlformats.org/presentationml/2006/main" xmlns:m="http://schemas.openxmlformats.org/officeDocument/2006/math" xmlns:w="http://schemas.openxmlformats.org/wordprocessingml/2006/main" matchingName="" preserve="1" showMasterPhAnim="0" showMasterSp="1" userDrawn="1">
   <p:cSld name="DEFAULT">
     <p:bg>
       <p:bgRef idx="1001">
@@ -736,7 +764,7 @@
         <p:cNvGrpSpPr/>
         <p:nvPr/>
       </p:nvGrpSpPr>
-      <p:grpSpPr>
+      <p:grpSpPr bwMode="auto">
         <a:xfrm>
           <a:off x="0" y="0"/>
           <a:ext cx="0" cy="0"/>
@@ -753,15 +781,15 @@
 </file>
 
 <file path=ppt/slideMasters/slideMaster1.xml><?xml version="1.0" encoding="utf-8"?>
-<p:sldMaster xmlns:a="http://schemas.openxmlformats.org/drawingml/2006/main" xmlns:r="http://schemas.openxmlformats.org/officeDocument/2006/relationships" xmlns:p="http://schemas.openxmlformats.org/presentationml/2006/main">
-  <p:cSld>
+<p:sldMaster xmlns:a="http://schemas.openxmlformats.org/drawingml/2006/main" xmlns:r="http://schemas.openxmlformats.org/officeDocument/2006/relationships" xmlns:p="http://schemas.openxmlformats.org/presentationml/2006/main" xmlns:m="http://schemas.openxmlformats.org/officeDocument/2006/math" xmlns:w="http://schemas.openxmlformats.org/wordprocessingml/2006/main" preserve="0">
+  <p:cSld name="">
     <p:spTree>
       <p:nvGrpSpPr>
         <p:cNvPr id="1" name=""/>
         <p:cNvGrpSpPr/>
         <p:nvPr/>
       </p:nvGrpSpPr>
-      <p:grpSpPr>
+      <p:grpSpPr bwMode="auto">
         <a:xfrm>
           <a:off x="0" y="0"/>
           <a:ext cx="0" cy="0"/>
@@ -775,15 +803,15 @@
   <p:sldLayoutIdLst>
     <p:sldLayoutId id="2147483649" r:id="rId1"/>
   </p:sldLayoutIdLst>
-  <p:hf sldNum="0" hdr="0" ftr="0" dt="0"/>
+  <p:hf dt="0" ftr="0" hdr="0" sldNum="0"/>
   <p:txStyles>
     <p:titleStyle>
-      <a:lvl1pPr algn="ctr" defTabSz="914400" rtl="0" eaLnBrk="1" latinLnBrk="0" hangingPunct="1">
+      <a:lvl1pPr algn="ctr" defTabSz="914400" rtl="0">
         <a:spcBef>
-          <a:spcPct val="0"/>
+          <a:spcPts val="0"/>
         </a:spcBef>
         <a:buNone/>
-        <a:defRPr sz="4400" kern="1200">
+        <a:defRPr sz="4400">
           <a:solidFill>
             <a:schemeClr val="tx1"/>
           </a:solidFill>
@@ -794,13 +822,13 @@
       </a:lvl1pPr>
     </p:titleStyle>
     <p:bodyStyle>
-      <a:lvl1pPr marL="342900" indent="-342900" algn="l" defTabSz="914400" rtl="0" eaLnBrk="1" latinLnBrk="0" hangingPunct="1">
+      <a:lvl1pPr marL="342900" indent="-342900" algn="l" defTabSz="914400" rtl="0">
         <a:spcBef>
-          <a:spcPct val="20000"/>
+          <a:spcPts val="0"/>
         </a:spcBef>
-        <a:buFont typeface="Arial" pitchFamily="34" charset="0"/>
+        <a:buFont typeface="Arial"/>
         <a:buChar char="•"/>
-        <a:defRPr sz="3200" kern="1200">
+        <a:defRPr sz="3200">
           <a:solidFill>
             <a:schemeClr val="tx1"/>
           </a:solidFill>
@@ -809,13 +837,13 @@
           <a:cs typeface="+mn-cs"/>
         </a:defRPr>
       </a:lvl1pPr>
-      <a:lvl2pPr marL="742950" indent="-285750" algn="l" defTabSz="914400" rtl="0" eaLnBrk="1" latinLnBrk="0" hangingPunct="1">
+      <a:lvl2pPr marL="742950" indent="-285750" algn="l" defTabSz="914400" rtl="0">
         <a:spcBef>
-          <a:spcPct val="20000"/>
+          <a:spcPts val="0"/>
         </a:spcBef>
-        <a:buFont typeface="Arial" pitchFamily="34" charset="0"/>
+        <a:buFont typeface="Arial"/>
         <a:buChar char="–"/>
-        <a:defRPr sz="2800" kern="1200">
+        <a:defRPr sz="2800">
           <a:solidFill>
             <a:schemeClr val="tx1"/>
           </a:solidFill>
@@ -824,13 +852,13 @@
           <a:cs typeface="+mn-cs"/>
         </a:defRPr>
       </a:lvl2pPr>
-      <a:lvl3pPr marL="1143000" indent="-228600" algn="l" defTabSz="914400" rtl="0" eaLnBrk="1" latinLnBrk="0" hangingPunct="1">
+      <a:lvl3pPr marL="1143000" indent="-228600" algn="l" defTabSz="914400" rtl="0">
         <a:spcBef>
-          <a:spcPct val="20000"/>
+          <a:spcPts val="0"/>
         </a:spcBef>
-        <a:buFont typeface="Arial" pitchFamily="34" charset="0"/>
+        <a:buFont typeface="Arial"/>
         <a:buChar char="•"/>
-        <a:defRPr sz="2400" kern="1200">
+        <a:defRPr sz="2400">
           <a:solidFill>
             <a:schemeClr val="tx1"/>
           </a:solidFill>
@@ -839,13 +867,13 @@
           <a:cs typeface="+mn-cs"/>
         </a:defRPr>
       </a:lvl3pPr>
-      <a:lvl4pPr marL="1600200" indent="-228600" algn="l" defTabSz="914400" rtl="0" eaLnBrk="1" latinLnBrk="0" hangingPunct="1">
+      <a:lvl4pPr marL="1600200" indent="-228600" algn="l" defTabSz="914400" rtl="0">
         <a:spcBef>
-          <a:spcPct val="20000"/>
+          <a:spcPts val="0"/>
         </a:spcBef>
-        <a:buFont typeface="Arial" pitchFamily="34" charset="0"/>
+        <a:buFont typeface="Arial"/>
         <a:buChar char="–"/>
-        <a:defRPr sz="2000" kern="1200">
+        <a:defRPr sz="2000">
           <a:solidFill>
             <a:schemeClr val="tx1"/>
           </a:solidFill>
@@ -854,13 +882,13 @@
           <a:cs typeface="+mn-cs"/>
         </a:defRPr>
       </a:lvl4pPr>
-      <a:lvl5pPr marL="2057400" indent="-228600" algn="l" defTabSz="914400" rtl="0" eaLnBrk="1" latinLnBrk="0" hangingPunct="1">
+      <a:lvl5pPr marL="2057400" indent="-228600" algn="l" defTabSz="914400" rtl="0">
         <a:spcBef>
-          <a:spcPct val="20000"/>
+          <a:spcPts val="0"/>
         </a:spcBef>
-        <a:buFont typeface="Arial" pitchFamily="34" charset="0"/>
+        <a:buFont typeface="Arial"/>
         <a:buChar char="»"/>
-        <a:defRPr sz="2000" kern="1200">
+        <a:defRPr sz="2000">
           <a:solidFill>
             <a:schemeClr val="tx1"/>
           </a:solidFill>
@@ -869,13 +897,13 @@
           <a:cs typeface="+mn-cs"/>
         </a:defRPr>
       </a:lvl5pPr>
-      <a:lvl6pPr marL="2514600" indent="-228600" algn="l" defTabSz="914400" rtl="0" eaLnBrk="1" latinLnBrk="0" hangingPunct="1">
+      <a:lvl6pPr marL="2514600" indent="-228600" algn="l" defTabSz="914400" rtl="0">
         <a:spcBef>
-          <a:spcPct val="20000"/>
+          <a:spcPts val="0"/>
         </a:spcBef>
-        <a:buFont typeface="Arial" pitchFamily="34" charset="0"/>
+        <a:buFont typeface="Arial"/>
         <a:buChar char="•"/>
-        <a:defRPr sz="2000" kern="1200">
+        <a:defRPr sz="2000">
           <a:solidFill>
             <a:schemeClr val="tx1"/>
           </a:solidFill>
@@ -884,13 +912,13 @@
           <a:cs typeface="+mn-cs"/>
         </a:defRPr>
       </a:lvl6pPr>
-      <a:lvl7pPr marL="2971800" indent="-228600" algn="l" defTabSz="914400" rtl="0" eaLnBrk="1" latinLnBrk="0" hangingPunct="1">
+      <a:lvl7pPr marL="2971800" indent="-228600" algn="l" defTabSz="914400" rtl="0">
         <a:spcBef>
-          <a:spcPct val="20000"/>
+          <a:spcPts val="0"/>
         </a:spcBef>
-        <a:buFont typeface="Arial" pitchFamily="34" charset="0"/>
+        <a:buFont typeface="Arial"/>
         <a:buChar char="•"/>
-        <a:defRPr sz="2000" kern="1200">
+        <a:defRPr sz="2000">
           <a:solidFill>
             <a:schemeClr val="tx1"/>
           </a:solidFill>
@@ -899,13 +927,13 @@
           <a:cs typeface="+mn-cs"/>
         </a:defRPr>
       </a:lvl7pPr>
-      <a:lvl8pPr marL="3429000" indent="-228600" algn="l" defTabSz="914400" rtl="0" eaLnBrk="1" latinLnBrk="0" hangingPunct="1">
+      <a:lvl8pPr marL="3429000" indent="-228600" algn="l" defTabSz="914400" rtl="0">
         <a:spcBef>
-          <a:spcPct val="20000"/>
+          <a:spcPts val="0"/>
         </a:spcBef>
-        <a:buFont typeface="Arial" pitchFamily="34" charset="0"/>
+        <a:buFont typeface="Arial"/>
         <a:buChar char="•"/>
-        <a:defRPr sz="2000" kern="1200">
+        <a:defRPr sz="2000">
           <a:solidFill>
             <a:schemeClr val="tx1"/>
           </a:solidFill>
@@ -914,13 +942,13 @@
           <a:cs typeface="+mn-cs"/>
         </a:defRPr>
       </a:lvl8pPr>
-      <a:lvl9pPr marL="3886200" indent="-228600" algn="l" defTabSz="914400" rtl="0" eaLnBrk="1" latinLnBrk="0" hangingPunct="1">
+      <a:lvl9pPr marL="3886200" indent="-228600" algn="l" defTabSz="914400" rtl="0">
         <a:spcBef>
-          <a:spcPct val="20000"/>
+          <a:spcPts val="0"/>
         </a:spcBef>
-        <a:buFont typeface="Arial" pitchFamily="34" charset="0"/>
+        <a:buFont typeface="Arial"/>
         <a:buChar char="•"/>
-        <a:defRPr sz="2000" kern="1200">
+        <a:defRPr sz="2000">
           <a:solidFill>
             <a:schemeClr val="tx1"/>
           </a:solidFill>
@@ -934,8 +962,8 @@
       <a:defPPr>
         <a:defRPr lang="en-US"/>
       </a:defPPr>
-      <a:lvl1pPr marL="0" algn="l" defTabSz="914400" rtl="0" eaLnBrk="1" latinLnBrk="0" hangingPunct="1">
-        <a:defRPr sz="1800" kern="1200">
+      <a:lvl1pPr marL="0" algn="l" defTabSz="914400" rtl="0">
+        <a:defRPr sz="1800">
           <a:solidFill>
             <a:schemeClr val="tx1"/>
           </a:solidFill>
@@ -944,8 +972,8 @@
           <a:cs typeface="+mn-cs"/>
         </a:defRPr>
       </a:lvl1pPr>
-      <a:lvl2pPr marL="457200" algn="l" defTabSz="914400" rtl="0" eaLnBrk="1" latinLnBrk="0" hangingPunct="1">
-        <a:defRPr sz="1800" kern="1200">
+      <a:lvl2pPr marL="457200" algn="l" defTabSz="914400" rtl="0">
+        <a:defRPr sz="1800">
           <a:solidFill>
             <a:schemeClr val="tx1"/>
           </a:solidFill>
@@ -954,8 +982,8 @@
           <a:cs typeface="+mn-cs"/>
         </a:defRPr>
       </a:lvl2pPr>
-      <a:lvl3pPr marL="914400" algn="l" defTabSz="914400" rtl="0" eaLnBrk="1" latinLnBrk="0" hangingPunct="1">
-        <a:defRPr sz="1800" kern="1200">
+      <a:lvl3pPr marL="914400" algn="l" defTabSz="914400" rtl="0">
+        <a:defRPr sz="1800">
           <a:solidFill>
             <a:schemeClr val="tx1"/>
           </a:solidFill>
@@ -964,8 +992,8 @@
           <a:cs typeface="+mn-cs"/>
         </a:defRPr>
       </a:lvl3pPr>
-      <a:lvl4pPr marL="1371600" algn="l" defTabSz="914400" rtl="0" eaLnBrk="1" latinLnBrk="0" hangingPunct="1">
-        <a:defRPr sz="1800" kern="1200">
+      <a:lvl4pPr marL="1371600" algn="l" defTabSz="914400" rtl="0">
+        <a:defRPr sz="1800">
           <a:solidFill>
             <a:schemeClr val="tx1"/>
           </a:solidFill>
@@ -974,8 +1002,8 @@
           <a:cs typeface="+mn-cs"/>
         </a:defRPr>
       </a:lvl4pPr>
-      <a:lvl5pPr marL="1828800" algn="l" defTabSz="914400" rtl="0" eaLnBrk="1" latinLnBrk="0" hangingPunct="1">
-        <a:defRPr sz="1800" kern="1200">
+      <a:lvl5pPr marL="1828800" algn="l" defTabSz="914400" rtl="0">
+        <a:defRPr sz="1800">
           <a:solidFill>
             <a:schemeClr val="tx1"/>
           </a:solidFill>
@@ -984,8 +1012,8 @@
           <a:cs typeface="+mn-cs"/>
         </a:defRPr>
       </a:lvl5pPr>
-      <a:lvl6pPr marL="2286000" algn="l" defTabSz="914400" rtl="0" eaLnBrk="1" latinLnBrk="0" hangingPunct="1">
-        <a:defRPr sz="1800" kern="1200">
+      <a:lvl6pPr marL="2286000" algn="l" defTabSz="914400" rtl="0">
+        <a:defRPr sz="1800">
           <a:solidFill>
             <a:schemeClr val="tx1"/>
           </a:solidFill>
@@ -994,8 +1022,8 @@
           <a:cs typeface="+mn-cs"/>
         </a:defRPr>
       </a:lvl6pPr>
-      <a:lvl7pPr marL="2743200" algn="l" defTabSz="914400" rtl="0" eaLnBrk="1" latinLnBrk="0" hangingPunct="1">
-        <a:defRPr sz="1800" kern="1200">
+      <a:lvl7pPr marL="2743200" algn="l" defTabSz="914400" rtl="0">
+        <a:defRPr sz="1800">
           <a:solidFill>
             <a:schemeClr val="tx1"/>
           </a:solidFill>
@@ -1004,8 +1032,8 @@
           <a:cs typeface="+mn-cs"/>
         </a:defRPr>
       </a:lvl7pPr>
-      <a:lvl8pPr marL="3200400" algn="l" defTabSz="914400" rtl="0" eaLnBrk="1" latinLnBrk="0" hangingPunct="1">
-        <a:defRPr sz="1800" kern="1200">
+      <a:lvl8pPr marL="3200400" algn="l" defTabSz="914400" rtl="0">
+        <a:defRPr sz="1800">
           <a:solidFill>
             <a:schemeClr val="tx1"/>
           </a:solidFill>
@@ -1014,8 +1042,8 @@
           <a:cs typeface="+mn-cs"/>
         </a:defRPr>
       </a:lvl8pPr>
-      <a:lvl9pPr marL="3657600" algn="l" defTabSz="914400" rtl="0" eaLnBrk="1" latinLnBrk="0" hangingPunct="1">
-        <a:defRPr sz="1800" kern="1200">
+      <a:lvl9pPr marL="3657600" algn="l" defTabSz="914400" rtl="0">
+        <a:defRPr sz="1800">
           <a:solidFill>
             <a:schemeClr val="tx1"/>
           </a:solidFill>
@@ -1030,10 +1058,10 @@
 </file>
 
 <file path=ppt/slides/slide1.xml><?xml version="1.0" encoding="utf-8"?>
-<p:sld xmlns:a="http://schemas.openxmlformats.org/drawingml/2006/main" xmlns:r="http://schemas.openxmlformats.org/officeDocument/2006/relationships" xmlns:p="http://schemas.openxmlformats.org/presentationml/2006/main">
+<p:sld xmlns:a="http://schemas.openxmlformats.org/drawingml/2006/main" xmlns:r="http://schemas.openxmlformats.org/officeDocument/2006/relationships" xmlns:p="http://schemas.openxmlformats.org/presentationml/2006/main" xmlns:m="http://schemas.openxmlformats.org/officeDocument/2006/math" xmlns:w="http://schemas.openxmlformats.org/wordprocessingml/2006/main" xmlns:mc="http://schemas.openxmlformats.org/markup-compatibility/2006" showMasterPhAnim="0" showMasterSp="1" show="1">
   <p:cSld name="Slide 1">
     <p:bg>
-      <p:bgPr>
+      <p:bgPr shadeToTitle="0">
         <a:solidFill>
           <a:srgbClr val="FFFFFF"/>
         </a:solidFill>
@@ -1045,7 +1073,7 @@
         <p:cNvGrpSpPr/>
         <p:nvPr/>
       </p:nvGrpSpPr>
-      <p:grpSpPr>
+      <p:grpSpPr bwMode="auto">
         <a:xfrm>
           <a:off x="0" y="0"/>
           <a:ext cx="0" cy="0"/>
@@ -1055,11 +1083,11 @@
       </p:grpSpPr>
       <p:sp>
         <p:nvSpPr>
-          <p:cNvPr id="2" name="Text 0"/>
-          <p:cNvSpPr/>
-          <p:nvPr/>
-        </p:nvSpPr>
-        <p:spPr>
+          <p:cNvPr id="1050592267" name="Text 0"/>
+          <p:cNvSpPr/>
+          <p:nvPr/>
+        </p:nvSpPr>
+        <p:spPr bwMode="auto">
           <a:xfrm>
             <a:off x="685800" y="502920"/>
             <a:ext cx="10789920" cy="274320"/>
@@ -1074,31 +1102,32 @@
           <a:bodyPr wrap="square" rtlCol="0" anchor="ctr"/>
           <a:lstStyle/>
           <a:p>
-            <a:pPr indent="0" marL="0">
-              <a:buNone/>
-            </a:pPr>
-            <a:r>
-              <a:rPr lang="en-US" sz="1200" b="1" spc="120" kern="0" dirty="0">
+            <a:pPr marL="0" indent="0">
+              <a:buNone/>
+              <a:defRPr/>
+            </a:pPr>
+            <a:r>
+              <a:rPr lang="en-US" sz="1200" b="1" spc="120">
                 <a:solidFill>
                   <a:srgbClr val="C9A227"/>
                 </a:solidFill>
-                <a:latin typeface="Calibri" pitchFamily="34" charset="0"/>
-                <a:ea typeface="Calibri" pitchFamily="34" charset="-122"/>
-                <a:cs typeface="Calibri" pitchFamily="34" charset="-120"/>
+                <a:latin typeface="Calibri"/>
+                <a:ea typeface="Calibri"/>
+                <a:cs typeface="Calibri"/>
               </a:rPr>
               <a:t>WHAT THE CUSTOMER GETS</a:t>
             </a:r>
-            <a:endParaRPr lang="en-US" sz="1200" dirty="0"/>
-          </a:p>
-        </p:txBody>
-      </p:sp>
-      <p:sp>
-        <p:nvSpPr>
-          <p:cNvPr id="3" name="Text 1"/>
-          <p:cNvSpPr/>
-          <p:nvPr/>
-        </p:nvSpPr>
-        <p:spPr>
+            <a:endParaRPr lang="en-US" sz="1200"/>
+          </a:p>
+        </p:txBody>
+      </p:sp>
+      <p:sp>
+        <p:nvSpPr>
+          <p:cNvPr id="846206062" name="Text 1"/>
+          <p:cNvSpPr/>
+          <p:nvPr/>
+        </p:nvSpPr>
+        <p:spPr bwMode="auto">
           <a:xfrm>
             <a:off x="685800" y="804672"/>
             <a:ext cx="10789920" cy="640080"/>
@@ -1113,31 +1142,32 @@
           <a:bodyPr wrap="square" rtlCol="0" anchor="ctr"/>
           <a:lstStyle/>
           <a:p>
-            <a:pPr indent="0" marL="0">
-              <a:buNone/>
-            </a:pPr>
-            <a:r>
-              <a:rPr lang="en-US" sz="3800" b="1" dirty="0">
+            <a:pPr marL="0" indent="0">
+              <a:buNone/>
+              <a:defRPr/>
+            </a:pPr>
+            <a:r>
+              <a:rPr lang="en-US" sz="3800" b="1">
                 <a:solidFill>
                   <a:srgbClr val="0B5D3B"/>
                 </a:solidFill>
-                <a:latin typeface="Cambria" pitchFamily="34" charset="0"/>
-                <a:ea typeface="Cambria" pitchFamily="34" charset="-122"/>
-                <a:cs typeface="Cambria" pitchFamily="34" charset="-120"/>
+                <a:latin typeface="Cambria"/>
+                <a:ea typeface="Cambria"/>
+                <a:cs typeface="Cambria"/>
               </a:rPr>
               <a:t>For the customer</a:t>
             </a:r>
-            <a:endParaRPr lang="en-US" sz="3800" dirty="0"/>
-          </a:p>
-        </p:txBody>
-      </p:sp>
-      <p:sp>
-        <p:nvSpPr>
-          <p:cNvPr id="4" name="Shape 2"/>
-          <p:cNvSpPr/>
-          <p:nvPr/>
-        </p:nvSpPr>
-        <p:spPr>
+            <a:endParaRPr lang="en-US" sz="3800"/>
+          </a:p>
+        </p:txBody>
+      </p:sp>
+      <p:sp>
+        <p:nvSpPr>
+          <p:cNvPr id="1929003010" name="Shape 2"/>
+          <p:cNvSpPr/>
+          <p:nvPr/>
+        </p:nvSpPr>
+        <p:spPr bwMode="auto">
           <a:xfrm>
             <a:off x="685800" y="1965960"/>
             <a:ext cx="3291840" cy="2971800"/>
@@ -1160,11 +1190,11 @@
       </p:sp>
       <p:sp>
         <p:nvSpPr>
-          <p:cNvPr id="5" name="Text 3"/>
-          <p:cNvSpPr/>
-          <p:nvPr/>
-        </p:nvSpPr>
-        <p:spPr>
+          <p:cNvPr id="133335729" name="Text 3"/>
+          <p:cNvSpPr/>
+          <p:nvPr/>
+        </p:nvSpPr>
+        <p:spPr bwMode="auto">
           <a:xfrm>
             <a:off x="1005840" y="2350008"/>
             <a:ext cx="2651760" cy="777240"/>
@@ -1179,48 +1209,50 @@
           <a:bodyPr wrap="square" lIns="0" tIns="0" rIns="0" bIns="0" rtlCol="0" anchor="t"/>
           <a:lstStyle/>
           <a:p>
-            <a:pPr indent="0" marL="0">
-              <a:buNone/>
-            </a:pPr>
-            <a:r>
-              <a:rPr lang="en-US" sz="2100" b="1" dirty="0">
+            <a:pPr marL="0" indent="0">
+              <a:buNone/>
+              <a:defRPr/>
+            </a:pPr>
+            <a:r>
+              <a:rPr lang="en-US" sz="2100" b="1">
                 <a:solidFill>
                   <a:srgbClr val="0B5D3B"/>
                 </a:solidFill>
-                <a:latin typeface="Calibri" pitchFamily="34" charset="0"/>
-                <a:ea typeface="Calibri" pitchFamily="34" charset="-122"/>
-                <a:cs typeface="Calibri" pitchFamily="34" charset="-120"/>
+                <a:latin typeface="Calibri"/>
+                <a:ea typeface="Calibri"/>
+                <a:cs typeface="Calibri"/>
               </a:rPr>
               <a:t>Advice they</a:t>
             </a:r>
-            <a:endParaRPr lang="en-US" sz="2100" dirty="0"/>
-          </a:p>
-          <a:p>
-            <a:pPr indent="0" marL="0">
-              <a:buNone/>
-            </a:pPr>
-            <a:r>
-              <a:rPr lang="en-US" sz="2100" b="1" dirty="0">
+            <a:endParaRPr lang="en-US" sz="2100"/>
+          </a:p>
+          <a:p>
+            <a:pPr marL="0" indent="0">
+              <a:buNone/>
+              <a:defRPr/>
+            </a:pPr>
+            <a:r>
+              <a:rPr lang="en-US" sz="2100" b="1">
                 <a:solidFill>
                   <a:srgbClr val="0B5D3B"/>
                 </a:solidFill>
-                <a:latin typeface="Calibri" pitchFamily="34" charset="0"/>
-                <a:ea typeface="Calibri" pitchFamily="34" charset="-122"/>
-                <a:cs typeface="Calibri" pitchFamily="34" charset="-120"/>
+                <a:latin typeface="Calibri"/>
+                <a:ea typeface="Calibri"/>
+                <a:cs typeface="Calibri"/>
               </a:rPr>
               <a:t>can trust</a:t>
             </a:r>
-            <a:endParaRPr lang="en-US" sz="2100" dirty="0"/>
-          </a:p>
-        </p:txBody>
-      </p:sp>
-      <p:sp>
-        <p:nvSpPr>
-          <p:cNvPr id="6" name="Text 4"/>
-          <p:cNvSpPr/>
-          <p:nvPr/>
-        </p:nvSpPr>
-        <p:spPr>
+            <a:endParaRPr lang="en-US" sz="2100"/>
+          </a:p>
+        </p:txBody>
+      </p:sp>
+      <p:sp>
+        <p:nvSpPr>
+          <p:cNvPr id="1966542032" name="Text 4"/>
+          <p:cNvSpPr/>
+          <p:nvPr/>
+        </p:nvSpPr>
+        <p:spPr bwMode="auto">
           <a:xfrm>
             <a:off x="1005840" y="3291840"/>
             <a:ext cx="2651760" cy="1280160"/>
@@ -1235,34 +1267,35 @@
           <a:bodyPr wrap="square" lIns="0" tIns="0" rIns="0" bIns="0" rtlCol="0" anchor="t"/>
           <a:lstStyle/>
           <a:p>
-            <a:pPr indent="0" marL="0">
+            <a:pPr marL="0" indent="0">
               <a:lnSpc>
                 <a:spcPts val="2100"/>
               </a:lnSpc>
               <a:buNone/>
-            </a:pPr>
-            <a:r>
-              <a:rPr lang="en-US" sz="1450" dirty="0">
+              <a:defRPr/>
+            </a:pPr>
+            <a:r>
+              <a:rPr lang="en-US" sz="1450">
                 <a:solidFill>
                   <a:srgbClr val="1A1A1A"/>
                 </a:solidFill>
-                <a:latin typeface="Calibri" pitchFamily="34" charset="0"/>
-                <a:ea typeface="Calibri" pitchFamily="34" charset="-122"/>
-                <a:cs typeface="Calibri" pitchFamily="34" charset="-120"/>
+                <a:latin typeface="Calibri"/>
+                <a:ea typeface="Calibri"/>
+                <a:cs typeface="Calibri"/>
               </a:rPr>
               <a:t>Because the engine is willing to recommend nothing at all when nothing is the right answer.</a:t>
             </a:r>
-            <a:endParaRPr lang="en-US" sz="1450" dirty="0"/>
-          </a:p>
-        </p:txBody>
-      </p:sp>
-      <p:sp>
-        <p:nvSpPr>
-          <p:cNvPr id="7" name="Shape 5"/>
-          <p:cNvSpPr/>
-          <p:nvPr/>
-        </p:nvSpPr>
-        <p:spPr>
+            <a:endParaRPr lang="en-US" sz="1450"/>
+          </a:p>
+        </p:txBody>
+      </p:sp>
+      <p:sp>
+        <p:nvSpPr>
+          <p:cNvPr id="1968544361" name="Shape 5"/>
+          <p:cNvSpPr/>
+          <p:nvPr/>
+        </p:nvSpPr>
+        <p:spPr bwMode="auto">
           <a:xfrm>
             <a:off x="4434840" y="1965960"/>
             <a:ext cx="3291840" cy="2971800"/>
@@ -1285,11 +1318,11 @@
       </p:sp>
       <p:sp>
         <p:nvSpPr>
-          <p:cNvPr id="8" name="Text 6"/>
-          <p:cNvSpPr/>
-          <p:nvPr/>
-        </p:nvSpPr>
-        <p:spPr>
+          <p:cNvPr id="1193667066" name="Text 6"/>
+          <p:cNvSpPr/>
+          <p:nvPr/>
+        </p:nvSpPr>
+        <p:spPr bwMode="auto">
           <a:xfrm>
             <a:off x="4754880" y="2350008"/>
             <a:ext cx="2651760" cy="777240"/>
@@ -1304,48 +1337,50 @@
           <a:bodyPr wrap="square" lIns="0" tIns="0" rIns="0" bIns="0" rtlCol="0" anchor="t"/>
           <a:lstStyle/>
           <a:p>
-            <a:pPr indent="0" marL="0">
-              <a:buNone/>
-            </a:pPr>
-            <a:r>
-              <a:rPr lang="en-US" sz="2100" b="1" dirty="0">
+            <a:pPr marL="0" indent="0">
+              <a:buNone/>
+              <a:defRPr/>
+            </a:pPr>
+            <a:r>
+              <a:rPr lang="en-US" sz="2100" b="1">
                 <a:solidFill>
                   <a:srgbClr val="0B5D3B"/>
                 </a:solidFill>
-                <a:latin typeface="Calibri" pitchFamily="34" charset="0"/>
-                <a:ea typeface="Calibri" pitchFamily="34" charset="-122"/>
-                <a:cs typeface="Calibri" pitchFamily="34" charset="-120"/>
+                <a:latin typeface="Calibri"/>
+                <a:ea typeface="Calibri"/>
+                <a:cs typeface="Calibri"/>
               </a:rPr>
               <a:t>Security they</a:t>
             </a:r>
-            <a:endParaRPr lang="en-US" sz="2100" dirty="0"/>
-          </a:p>
-          <a:p>
-            <a:pPr indent="0" marL="0">
-              <a:buNone/>
-            </a:pPr>
-            <a:r>
-              <a:rPr lang="en-US" sz="2100" b="1" dirty="0">
+            <a:endParaRPr lang="en-US" sz="2100"/>
+          </a:p>
+          <a:p>
+            <a:pPr marL="0" indent="0">
+              <a:buNone/>
+              <a:defRPr/>
+            </a:pPr>
+            <a:r>
+              <a:rPr lang="en-US" sz="2100" b="1">
                 <a:solidFill>
                   <a:srgbClr val="0B5D3B"/>
                 </a:solidFill>
-                <a:latin typeface="Calibri" pitchFamily="34" charset="0"/>
-                <a:ea typeface="Calibri" pitchFamily="34" charset="-122"/>
-                <a:cs typeface="Calibri" pitchFamily="34" charset="-120"/>
+                <a:latin typeface="Calibri"/>
+                <a:ea typeface="Calibri"/>
+                <a:cs typeface="Calibri"/>
               </a:rPr>
               <a:t>can understand</a:t>
             </a:r>
-            <a:endParaRPr lang="en-US" sz="2100" dirty="0"/>
-          </a:p>
-        </p:txBody>
-      </p:sp>
-      <p:sp>
-        <p:nvSpPr>
-          <p:cNvPr id="9" name="Text 7"/>
-          <p:cNvSpPr/>
-          <p:nvPr/>
-        </p:nvSpPr>
-        <p:spPr>
+            <a:endParaRPr lang="en-US" sz="2100"/>
+          </a:p>
+        </p:txBody>
+      </p:sp>
+      <p:sp>
+        <p:nvSpPr>
+          <p:cNvPr id="956568346" name="Text 7"/>
+          <p:cNvSpPr/>
+          <p:nvPr/>
+        </p:nvSpPr>
+        <p:spPr bwMode="auto">
           <a:xfrm>
             <a:off x="4754880" y="3291840"/>
             <a:ext cx="2651760" cy="1280160"/>
@@ -1360,34 +1395,35 @@
           <a:bodyPr wrap="square" lIns="0" tIns="0" rIns="0" bIns="0" rtlCol="0" anchor="t"/>
           <a:lstStyle/>
           <a:p>
-            <a:pPr indent="0" marL="0">
+            <a:pPr marL="0" indent="0">
               <a:lnSpc>
                 <a:spcPts val="2100"/>
               </a:lnSpc>
               <a:buNone/>
-            </a:pPr>
-            <a:r>
-              <a:rPr lang="en-US" sz="1450" dirty="0">
+              <a:defRPr/>
+            </a:pPr>
+            <a:r>
+              <a:rPr lang="en-US" sz="1450">
                 <a:solidFill>
                   <a:srgbClr val="1A1A1A"/>
                 </a:solidFill>
-                <a:latin typeface="Calibri" pitchFamily="34" charset="0"/>
-                <a:ea typeface="Calibri" pitchFamily="34" charset="-122"/>
-                <a:cs typeface="Calibri" pitchFamily="34" charset="-120"/>
+                <a:latin typeface="Calibri"/>
+                <a:ea typeface="Calibri"/>
+                <a:cs typeface="Calibri"/>
               </a:rPr>
               <a:t>Every check explained in plain language — in English, Hindi or Punjabi.</a:t>
             </a:r>
-            <a:endParaRPr lang="en-US" sz="1450" dirty="0"/>
-          </a:p>
-        </p:txBody>
-      </p:sp>
-      <p:sp>
-        <p:nvSpPr>
-          <p:cNvPr id="10" name="Shape 8"/>
-          <p:cNvSpPr/>
-          <p:nvPr/>
-        </p:nvSpPr>
-        <p:spPr>
+            <a:endParaRPr lang="en-US" sz="1450"/>
+          </a:p>
+        </p:txBody>
+      </p:sp>
+      <p:sp>
+        <p:nvSpPr>
+          <p:cNvPr id="215742532" name="Shape 8"/>
+          <p:cNvSpPr/>
+          <p:nvPr/>
+        </p:nvSpPr>
+        <p:spPr bwMode="auto">
           <a:xfrm>
             <a:off x="8183880" y="1965960"/>
             <a:ext cx="3291840" cy="2971800"/>
@@ -1410,11 +1446,11 @@
       </p:sp>
       <p:sp>
         <p:nvSpPr>
-          <p:cNvPr id="11" name="Text 9"/>
-          <p:cNvSpPr/>
-          <p:nvPr/>
-        </p:nvSpPr>
-        <p:spPr>
+          <p:cNvPr id="721912860" name="Text 9"/>
+          <p:cNvSpPr/>
+          <p:nvPr/>
+        </p:nvSpPr>
+        <p:spPr bwMode="auto">
           <a:xfrm>
             <a:off x="8503920" y="2350008"/>
             <a:ext cx="2651760" cy="777240"/>
@@ -1429,48 +1465,50 @@
           <a:bodyPr wrap="square" lIns="0" tIns="0" rIns="0" bIns="0" rtlCol="0" anchor="t"/>
           <a:lstStyle/>
           <a:p>
-            <a:pPr indent="0" marL="0">
-              <a:buNone/>
-            </a:pPr>
-            <a:r>
-              <a:rPr lang="en-US" sz="2100" b="1" dirty="0">
+            <a:pPr marL="0" indent="0">
+              <a:buNone/>
+              <a:defRPr/>
+            </a:pPr>
+            <a:r>
+              <a:rPr lang="en-US" sz="2100" b="1">
                 <a:solidFill>
                   <a:srgbClr val="0B5D3B"/>
                 </a:solidFill>
-                <a:latin typeface="Calibri" pitchFamily="34" charset="0"/>
-                <a:ea typeface="Calibri" pitchFamily="34" charset="-122"/>
-                <a:cs typeface="Calibri" pitchFamily="34" charset="-120"/>
+                <a:latin typeface="Calibri"/>
+                <a:ea typeface="Calibri"/>
+                <a:cs typeface="Calibri"/>
               </a:rPr>
               <a:t>One tap to say</a:t>
             </a:r>
-            <a:endParaRPr lang="en-US" sz="2100" dirty="0"/>
-          </a:p>
-          <a:p>
-            <a:pPr indent="0" marL="0">
-              <a:buNone/>
-            </a:pPr>
-            <a:r>
-              <a:rPr lang="en-US" sz="2100" b="1" dirty="0">
+            <a:endParaRPr lang="en-US" sz="2100"/>
+          </a:p>
+          <a:p>
+            <a:pPr marL="0" indent="0">
+              <a:buNone/>
+              <a:defRPr/>
+            </a:pPr>
+            <a:r>
+              <a:rPr lang="en-US" sz="2100" b="1">
                 <a:solidFill>
                   <a:srgbClr val="0B5D3B"/>
                 </a:solidFill>
-                <a:latin typeface="Calibri" pitchFamily="34" charset="0"/>
-                <a:ea typeface="Calibri" pitchFamily="34" charset="-122"/>
-                <a:cs typeface="Calibri" pitchFamily="34" charset="-120"/>
+                <a:latin typeface="Calibri"/>
+                <a:ea typeface="Calibri"/>
+                <a:cs typeface="Calibri"/>
               </a:rPr>
               <a:t>"this wasn't me"</a:t>
             </a:r>
-            <a:endParaRPr lang="en-US" sz="2100" dirty="0"/>
-          </a:p>
-        </p:txBody>
-      </p:sp>
-      <p:sp>
-        <p:nvSpPr>
-          <p:cNvPr id="12" name="Text 10"/>
-          <p:cNvSpPr/>
-          <p:nvPr/>
-        </p:nvSpPr>
-        <p:spPr>
+            <a:endParaRPr lang="en-US" sz="2100"/>
+          </a:p>
+        </p:txBody>
+      </p:sp>
+      <p:sp>
+        <p:nvSpPr>
+          <p:cNvPr id="618388683" name="Text 10"/>
+          <p:cNvSpPr/>
+          <p:nvPr/>
+        </p:nvSpPr>
+        <p:spPr bwMode="auto">
           <a:xfrm>
             <a:off x="8503920" y="3291840"/>
             <a:ext cx="2651760" cy="1280160"/>
@@ -1485,24 +1523,25 @@
           <a:bodyPr wrap="square" lIns="0" tIns="0" rIns="0" bIns="0" rtlCol="0" anchor="t"/>
           <a:lstStyle/>
           <a:p>
-            <a:pPr indent="0" marL="0">
+            <a:pPr marL="0" indent="0">
               <a:lnSpc>
                 <a:spcPts val="2100"/>
               </a:lnSpc>
               <a:buNone/>
-            </a:pPr>
-            <a:r>
-              <a:rPr lang="en-US" sz="1450" dirty="0">
+              <a:defRPr/>
+            </a:pPr>
+            <a:r>
+              <a:rPr lang="en-US" sz="1450">
                 <a:solidFill>
                   <a:srgbClr val="1A1A1A"/>
                 </a:solidFill>
-                <a:latin typeface="Calibri" pitchFamily="34" charset="0"/>
-                <a:ea typeface="Calibri" pitchFamily="34" charset="-122"/>
-                <a:cs typeface="Calibri" pitchFamily="34" charset="-120"/>
+                <a:latin typeface="Calibri"/>
+                <a:ea typeface="Calibri"/>
+                <a:cs typeface="Calibri"/>
               </a:rPr>
               <a:t>A held transaction is stopped and reported the moment the customer says it was not them.</a:t>
             </a:r>
-            <a:endParaRPr lang="en-US" sz="1450" dirty="0"/>
+            <a:endParaRPr lang="en-US" sz="1450"/>
           </a:p>
         </p:txBody>
       </p:sp>
@@ -1511,14 +1550,22 @@
   <p:clrMapOvr>
     <a:masterClrMapping/>
   </p:clrMapOvr>
+  <mc:AlternateContent xmlns:mc="http://schemas.openxmlformats.org/markup-compatibility/2006">
+    <mc:Choice xmlns:p159="http://schemas.microsoft.com/office/powerpoint/2015/09/main" xmlns:p14="http://schemas.microsoft.com/office/powerpoint/2010/main" Requires="p159">
+      <p:transition p14:dur="500" advClick="1"/>
+    </mc:Choice>
+    <mc:Fallback>
+      <p:transition advClick="1"/>
+    </mc:Fallback>
+  </mc:AlternateContent>
 </p:sld>
 </file>
 
 <file path=ppt/slides/slide2.xml><?xml version="1.0" encoding="utf-8"?>
-<p:sld xmlns:a="http://schemas.openxmlformats.org/drawingml/2006/main" xmlns:r="http://schemas.openxmlformats.org/officeDocument/2006/relationships" xmlns:p="http://schemas.openxmlformats.org/presentationml/2006/main">
+<p:sld xmlns:a="http://schemas.openxmlformats.org/drawingml/2006/main" xmlns:r="http://schemas.openxmlformats.org/officeDocument/2006/relationships" xmlns:p="http://schemas.openxmlformats.org/presentationml/2006/main" xmlns:m="http://schemas.openxmlformats.org/officeDocument/2006/math" xmlns:w="http://schemas.openxmlformats.org/wordprocessingml/2006/main" xmlns:mc="http://schemas.openxmlformats.org/markup-compatibility/2006" showMasterPhAnim="0" showMasterSp="1" show="1">
   <p:cSld name="Slide 2">
     <p:bg>
-      <p:bgPr>
+      <p:bgPr shadeToTitle="0">
         <a:solidFill>
           <a:srgbClr val="FFFFFF"/>
         </a:solidFill>
@@ -1530,7 +1577,7 @@
         <p:cNvGrpSpPr/>
         <p:nvPr/>
       </p:nvGrpSpPr>
-      <p:grpSpPr>
+      <p:grpSpPr bwMode="auto">
         <a:xfrm>
           <a:off x="0" y="0"/>
           <a:ext cx="0" cy="0"/>
@@ -1540,11 +1587,11 @@
       </p:grpSpPr>
       <p:sp>
         <p:nvSpPr>
-          <p:cNvPr id="2" name="Text 0"/>
-          <p:cNvSpPr/>
-          <p:nvPr/>
-        </p:nvSpPr>
-        <p:spPr>
+          <p:cNvPr id="939815007" name="Text 0"/>
+          <p:cNvSpPr/>
+          <p:nvPr/>
+        </p:nvSpPr>
+        <p:spPr bwMode="auto">
           <a:xfrm>
             <a:off x="685800" y="502920"/>
             <a:ext cx="10789920" cy="274320"/>
@@ -1559,31 +1606,32 @@
           <a:bodyPr wrap="square" rtlCol="0" anchor="ctr"/>
           <a:lstStyle/>
           <a:p>
-            <a:pPr indent="0" marL="0">
-              <a:buNone/>
-            </a:pPr>
-            <a:r>
-              <a:rPr lang="en-US" sz="1200" b="1" spc="120" kern="0" dirty="0">
+            <a:pPr marL="0" indent="0">
+              <a:buNone/>
+              <a:defRPr/>
+            </a:pPr>
+            <a:r>
+              <a:rPr lang="en-US" sz="1200" b="1" spc="120">
                 <a:solidFill>
                   <a:srgbClr val="C9A227"/>
                 </a:solidFill>
-                <a:latin typeface="Calibri" pitchFamily="34" charset="0"/>
-                <a:ea typeface="Calibri" pitchFamily="34" charset="-122"/>
-                <a:cs typeface="Calibri" pitchFamily="34" charset="-120"/>
+                <a:latin typeface="Calibri"/>
+                <a:ea typeface="Calibri"/>
+                <a:cs typeface="Calibri"/>
               </a:rPr>
               <a:t>WHAT THE BANK GETS</a:t>
             </a:r>
-            <a:endParaRPr lang="en-US" sz="1200" dirty="0"/>
-          </a:p>
-        </p:txBody>
-      </p:sp>
-      <p:sp>
-        <p:nvSpPr>
-          <p:cNvPr id="3" name="Text 1"/>
-          <p:cNvSpPr/>
-          <p:nvPr/>
-        </p:nvSpPr>
-        <p:spPr>
+            <a:endParaRPr lang="en-US" sz="1200"/>
+          </a:p>
+        </p:txBody>
+      </p:sp>
+      <p:sp>
+        <p:nvSpPr>
+          <p:cNvPr id="1608365551" name="Text 1"/>
+          <p:cNvSpPr/>
+          <p:nvPr/>
+        </p:nvSpPr>
+        <p:spPr bwMode="auto">
           <a:xfrm>
             <a:off x="685800" y="804672"/>
             <a:ext cx="10789920" cy="640080"/>
@@ -1598,31 +1646,32 @@
           <a:bodyPr wrap="square" rtlCol="0" anchor="ctr"/>
           <a:lstStyle/>
           <a:p>
-            <a:pPr indent="0" marL="0">
-              <a:buNone/>
-            </a:pPr>
-            <a:r>
-              <a:rPr lang="en-US" sz="3800" b="1" dirty="0">
+            <a:pPr marL="0" indent="0">
+              <a:buNone/>
+              <a:defRPr/>
+            </a:pPr>
+            <a:r>
+              <a:rPr lang="en-US" sz="3800" b="1">
                 <a:solidFill>
                   <a:srgbClr val="0B5D3B"/>
                 </a:solidFill>
-                <a:latin typeface="Cambria" pitchFamily="34" charset="0"/>
-                <a:ea typeface="Cambria" pitchFamily="34" charset="-122"/>
-                <a:cs typeface="Cambria" pitchFamily="34" charset="-120"/>
+                <a:latin typeface="Cambria"/>
+                <a:ea typeface="Cambria"/>
+                <a:cs typeface="Cambria"/>
               </a:rPr>
               <a:t>For the bank</a:t>
             </a:r>
-            <a:endParaRPr lang="en-US" sz="3800" dirty="0"/>
-          </a:p>
-        </p:txBody>
-      </p:sp>
-      <p:sp>
-        <p:nvSpPr>
-          <p:cNvPr id="4" name="Shape 2"/>
-          <p:cNvSpPr/>
-          <p:nvPr/>
-        </p:nvSpPr>
-        <p:spPr>
+            <a:endParaRPr lang="en-US" sz="3800"/>
+          </a:p>
+        </p:txBody>
+      </p:sp>
+      <p:sp>
+        <p:nvSpPr>
+          <p:cNvPr id="987072824" name="Shape 2"/>
+          <p:cNvSpPr/>
+          <p:nvPr/>
+        </p:nvSpPr>
+        <p:spPr bwMode="auto">
           <a:xfrm>
             <a:off x="685800" y="1965960"/>
             <a:ext cx="3291840" cy="2971800"/>
@@ -1645,11 +1694,11 @@
       </p:sp>
       <p:sp>
         <p:nvSpPr>
-          <p:cNvPr id="5" name="Text 3"/>
-          <p:cNvSpPr/>
-          <p:nvPr/>
-        </p:nvSpPr>
-        <p:spPr>
+          <p:cNvPr id="959053501" name="Text 3"/>
+          <p:cNvSpPr/>
+          <p:nvPr/>
+        </p:nvSpPr>
+        <p:spPr bwMode="auto">
           <a:xfrm>
             <a:off x="1005840" y="2350008"/>
             <a:ext cx="2651760" cy="777240"/>
@@ -1664,48 +1713,50 @@
           <a:bodyPr wrap="square" lIns="0" tIns="0" rIns="0" bIns="0" rtlCol="0" anchor="t"/>
           <a:lstStyle/>
           <a:p>
-            <a:pPr indent="0" marL="0">
-              <a:buNone/>
-            </a:pPr>
-            <a:r>
-              <a:rPr lang="en-US" sz="2100" b="1" dirty="0">
+            <a:pPr marL="0" indent="0">
+              <a:buNone/>
+              <a:defRPr/>
+            </a:pPr>
+            <a:r>
+              <a:rPr lang="en-US" sz="2100" b="1">
                 <a:solidFill>
                   <a:srgbClr val="0B5D3B"/>
                 </a:solidFill>
-                <a:latin typeface="Calibri" pitchFamily="34" charset="0"/>
-                <a:ea typeface="Calibri" pitchFamily="34" charset="-122"/>
-                <a:cs typeface="Calibri" pitchFamily="34" charset="-120"/>
+                <a:latin typeface="Calibri"/>
+                <a:ea typeface="Calibri"/>
+                <a:cs typeface="Calibri"/>
               </a:rPr>
               <a:t>Fraud stopped</a:t>
             </a:r>
-            <a:endParaRPr lang="en-US" sz="2100" dirty="0"/>
-          </a:p>
-          <a:p>
-            <a:pPr indent="0" marL="0">
-              <a:buNone/>
-            </a:pPr>
-            <a:r>
-              <a:rPr lang="en-US" sz="2100" b="1" dirty="0">
+            <a:endParaRPr lang="en-US" sz="2100"/>
+          </a:p>
+          <a:p>
+            <a:pPr marL="0" indent="0">
+              <a:buNone/>
+              <a:defRPr/>
+            </a:pPr>
+            <a:r>
+              <a:rPr lang="en-US" sz="2100" b="1">
                 <a:solidFill>
                   <a:srgbClr val="0B5D3B"/>
                 </a:solidFill>
-                <a:latin typeface="Calibri" pitchFamily="34" charset="0"/>
-                <a:ea typeface="Calibri" pitchFamily="34" charset="-122"/>
-                <a:cs typeface="Calibri" pitchFamily="34" charset="-120"/>
+                <a:latin typeface="Calibri"/>
+                <a:ea typeface="Calibri"/>
+                <a:cs typeface="Calibri"/>
               </a:rPr>
               <a:t>before money moves</a:t>
             </a:r>
-            <a:endParaRPr lang="en-US" sz="2100" dirty="0"/>
-          </a:p>
-        </p:txBody>
-      </p:sp>
-      <p:sp>
-        <p:nvSpPr>
-          <p:cNvPr id="6" name="Text 4"/>
-          <p:cNvSpPr/>
-          <p:nvPr/>
-        </p:nvSpPr>
-        <p:spPr>
+            <a:endParaRPr lang="en-US" sz="2100"/>
+          </a:p>
+        </p:txBody>
+      </p:sp>
+      <p:sp>
+        <p:nvSpPr>
+          <p:cNvPr id="2059791856" name="Text 4"/>
+          <p:cNvSpPr/>
+          <p:nvPr/>
+        </p:nvSpPr>
+        <p:spPr bwMode="auto">
           <a:xfrm>
             <a:off x="1005840" y="3291840"/>
             <a:ext cx="2651760" cy="1280160"/>
@@ -1720,34 +1771,35 @@
           <a:bodyPr wrap="square" lIns="0" tIns="0" rIns="0" bIns="0" rtlCol="0" anchor="t"/>
           <a:lstStyle/>
           <a:p>
-            <a:pPr indent="0" marL="0">
+            <a:pPr marL="0" indent="0">
               <a:lnSpc>
                 <a:spcPts val="2100"/>
               </a:lnSpc>
               <a:buNone/>
-            </a:pPr>
-            <a:r>
-              <a:rPr lang="en-US" sz="1450" dirty="0">
+              <a:defRPr/>
+            </a:pPr>
+            <a:r>
+              <a:rPr lang="en-US" sz="1450">
                 <a:solidFill>
                   <a:srgbClr val="1A1A1A"/>
                 </a:solidFill>
-                <a:latin typeface="Calibri" pitchFamily="34" charset="0"/>
-                <a:ea typeface="Calibri" pitchFamily="34" charset="-122"/>
-                <a:cs typeface="Calibri" pitchFamily="34" charset="-120"/>
+                <a:latin typeface="Calibri"/>
+                <a:ea typeface="Calibri"/>
+                <a:cs typeface="Calibri"/>
               </a:rPr>
               <a:t>Judged in-line on every investment — not reconciled after the funds have gone.</a:t>
             </a:r>
-            <a:endParaRPr lang="en-US" sz="1450" dirty="0"/>
-          </a:p>
-        </p:txBody>
-      </p:sp>
-      <p:sp>
-        <p:nvSpPr>
-          <p:cNvPr id="7" name="Shape 5"/>
-          <p:cNvSpPr/>
-          <p:nvPr/>
-        </p:nvSpPr>
-        <p:spPr>
+            <a:endParaRPr lang="en-US" sz="1450"/>
+          </a:p>
+        </p:txBody>
+      </p:sp>
+      <p:sp>
+        <p:nvSpPr>
+          <p:cNvPr id="795216051" name="Shape 5"/>
+          <p:cNvSpPr/>
+          <p:nvPr/>
+        </p:nvSpPr>
+        <p:spPr bwMode="auto">
           <a:xfrm>
             <a:off x="4434840" y="1965960"/>
             <a:ext cx="3291840" cy="2971800"/>
@@ -1770,11 +1822,11 @@
       </p:sp>
       <p:sp>
         <p:nvSpPr>
-          <p:cNvPr id="8" name="Text 6"/>
-          <p:cNvSpPr/>
-          <p:nvPr/>
-        </p:nvSpPr>
-        <p:spPr>
+          <p:cNvPr id="1789639785" name="Text 6"/>
+          <p:cNvSpPr/>
+          <p:nvPr/>
+        </p:nvSpPr>
+        <p:spPr bwMode="auto">
           <a:xfrm>
             <a:off x="4754880" y="2350008"/>
             <a:ext cx="2651760" cy="777240"/>
@@ -1789,48 +1841,50 @@
           <a:bodyPr wrap="square" lIns="0" tIns="0" rIns="0" bIns="0" rtlCol="0" anchor="t"/>
           <a:lstStyle/>
           <a:p>
-            <a:pPr indent="0" marL="0">
-              <a:buNone/>
-            </a:pPr>
-            <a:r>
-              <a:rPr lang="en-US" sz="2100" b="1" dirty="0">
+            <a:pPr marL="0" indent="0">
+              <a:buNone/>
+              <a:defRPr/>
+            </a:pPr>
+            <a:r>
+              <a:rPr lang="en-US" sz="2100" b="1">
                 <a:solidFill>
                   <a:srgbClr val="0B5D3B"/>
                 </a:solidFill>
-                <a:latin typeface="Calibri" pitchFamily="34" charset="0"/>
-                <a:ea typeface="Calibri" pitchFamily="34" charset="-122"/>
-                <a:cs typeface="Calibri" pitchFamily="34" charset="-120"/>
+                <a:latin typeface="Calibri"/>
+                <a:ea typeface="Calibri"/>
+                <a:cs typeface="Calibri"/>
               </a:rPr>
               <a:t>An audit trail that</a:t>
             </a:r>
-            <a:endParaRPr lang="en-US" sz="2100" dirty="0"/>
-          </a:p>
-          <a:p>
-            <a:pPr indent="0" marL="0">
-              <a:buNone/>
-            </a:pPr>
-            <a:r>
-              <a:rPr lang="en-US" sz="2100" b="1" dirty="0">
+            <a:endParaRPr lang="en-US" sz="2100"/>
+          </a:p>
+          <a:p>
+            <a:pPr marL="0" indent="0">
+              <a:buNone/>
+              <a:defRPr/>
+            </a:pPr>
+            <a:r>
+              <a:rPr lang="en-US" sz="2100" b="1">
                 <a:solidFill>
                   <a:srgbClr val="0B5D3B"/>
                 </a:solidFill>
-                <a:latin typeface="Calibri" pitchFamily="34" charset="0"/>
-                <a:ea typeface="Calibri" pitchFamily="34" charset="-122"/>
-                <a:cs typeface="Calibri" pitchFamily="34" charset="-120"/>
+                <a:latin typeface="Calibri"/>
+                <a:ea typeface="Calibri"/>
+                <a:cs typeface="Calibri"/>
               </a:rPr>
               <a:t>survives an insider</a:t>
             </a:r>
-            <a:endParaRPr lang="en-US" sz="2100" dirty="0"/>
-          </a:p>
-        </p:txBody>
-      </p:sp>
-      <p:sp>
-        <p:nvSpPr>
-          <p:cNvPr id="9" name="Text 7"/>
-          <p:cNvSpPr/>
-          <p:nvPr/>
-        </p:nvSpPr>
-        <p:spPr>
+            <a:endParaRPr lang="en-US" sz="2100"/>
+          </a:p>
+        </p:txBody>
+      </p:sp>
+      <p:sp>
+        <p:nvSpPr>
+          <p:cNvPr id="1758311598" name="Text 7"/>
+          <p:cNvSpPr/>
+          <p:nvPr/>
+        </p:nvSpPr>
+        <p:spPr bwMode="auto">
           <a:xfrm>
             <a:off x="4754880" y="3291840"/>
             <a:ext cx="2651760" cy="1280160"/>
@@ -1845,34 +1899,35 @@
           <a:bodyPr wrap="square" lIns="0" tIns="0" rIns="0" bIns="0" rtlCol="0" anchor="t"/>
           <a:lstStyle/>
           <a:p>
-            <a:pPr indent="0" marL="0">
+            <a:pPr marL="0" indent="0">
               <a:lnSpc>
                 <a:spcPts val="2100"/>
               </a:lnSpc>
               <a:buNone/>
-            </a:pPr>
-            <a:r>
-              <a:rPr lang="en-US" sz="1450" dirty="0">
+              <a:defRPr/>
+            </a:pPr>
+            <a:r>
+              <a:rPr lang="en-US" sz="1450">
                 <a:solidFill>
                   <a:srgbClr val="1A1A1A"/>
                 </a:solidFill>
-                <a:latin typeface="Calibri" pitchFamily="34" charset="0"/>
-                <a:ea typeface="Calibri" pitchFamily="34" charset="-122"/>
-                <a:cs typeface="Calibri" pitchFamily="34" charset="-120"/>
+                <a:latin typeface="Calibri"/>
+                <a:ea typeface="Calibri"/>
+                <a:cs typeface="Calibri"/>
               </a:rPr>
               <a:t>Four signed copies. Rewriting three of them still fails, because signatures beat head-count.</a:t>
             </a:r>
-            <a:endParaRPr lang="en-US" sz="1450" dirty="0"/>
-          </a:p>
-        </p:txBody>
-      </p:sp>
-      <p:sp>
-        <p:nvSpPr>
-          <p:cNvPr id="10" name="Shape 8"/>
-          <p:cNvSpPr/>
-          <p:nvPr/>
-        </p:nvSpPr>
-        <p:spPr>
+            <a:endParaRPr lang="en-US" sz="1450"/>
+          </a:p>
+        </p:txBody>
+      </p:sp>
+      <p:sp>
+        <p:nvSpPr>
+          <p:cNvPr id="1721183591" name="Shape 8"/>
+          <p:cNvSpPr/>
+          <p:nvPr/>
+        </p:nvSpPr>
+        <p:spPr bwMode="auto">
           <a:xfrm>
             <a:off x="8183880" y="1965960"/>
             <a:ext cx="3291840" cy="2971800"/>
@@ -1895,11 +1950,11 @@
       </p:sp>
       <p:sp>
         <p:nvSpPr>
-          <p:cNvPr id="11" name="Text 9"/>
-          <p:cNvSpPr/>
-          <p:nvPr/>
-        </p:nvSpPr>
-        <p:spPr>
+          <p:cNvPr id="386510630" name="Text 9"/>
+          <p:cNvSpPr/>
+          <p:nvPr/>
+        </p:nvSpPr>
+        <p:spPr bwMode="auto">
           <a:xfrm>
             <a:off x="8503920" y="2350008"/>
             <a:ext cx="2651760" cy="777240"/>
@@ -1914,48 +1969,50 @@
           <a:bodyPr wrap="square" lIns="0" tIns="0" rIns="0" bIns="0" rtlCol="0" anchor="t"/>
           <a:lstStyle/>
           <a:p>
-            <a:pPr indent="0" marL="0">
-              <a:buNone/>
-            </a:pPr>
-            <a:r>
-              <a:rPr lang="en-US" sz="2100" b="1" dirty="0">
+            <a:pPr marL="0" indent="0">
+              <a:buNone/>
+              <a:defRPr/>
+            </a:pPr>
+            <a:r>
+              <a:rPr lang="en-US" sz="2100" b="1">
                 <a:solidFill>
                   <a:srgbClr val="0B5D3B"/>
                 </a:solidFill>
-                <a:latin typeface="Calibri" pitchFamily="34" charset="0"/>
-                <a:ea typeface="Calibri" pitchFamily="34" charset="-122"/>
-                <a:cs typeface="Calibri" pitchFamily="34" charset="-120"/>
+                <a:latin typeface="Calibri"/>
+                <a:ea typeface="Calibri"/>
+                <a:cs typeface="Calibri"/>
               </a:rPr>
               <a:t>Decisions that can</a:t>
             </a:r>
-            <a:endParaRPr lang="en-US" sz="2100" dirty="0"/>
-          </a:p>
-          <a:p>
-            <a:pPr indent="0" marL="0">
-              <a:buNone/>
-            </a:pPr>
-            <a:r>
-              <a:rPr lang="en-US" sz="2100" b="1" dirty="0">
+            <a:endParaRPr lang="en-US" sz="2100"/>
+          </a:p>
+          <a:p>
+            <a:pPr marL="0" indent="0">
+              <a:buNone/>
+              <a:defRPr/>
+            </a:pPr>
+            <a:r>
+              <a:rPr lang="en-US" sz="2100" b="1">
                 <a:solidFill>
                   <a:srgbClr val="0B5D3B"/>
                 </a:solidFill>
-                <a:latin typeface="Calibri" pitchFamily="34" charset="0"/>
-                <a:ea typeface="Calibri" pitchFamily="34" charset="-122"/>
-                <a:cs typeface="Calibri" pitchFamily="34" charset="-120"/>
+                <a:latin typeface="Calibri"/>
+                <a:ea typeface="Calibri"/>
+                <a:cs typeface="Calibri"/>
               </a:rPr>
               <a:t>be defended</a:t>
             </a:r>
-            <a:endParaRPr lang="en-US" sz="2100" dirty="0"/>
-          </a:p>
-        </p:txBody>
-      </p:sp>
-      <p:sp>
-        <p:nvSpPr>
-          <p:cNvPr id="12" name="Text 10"/>
-          <p:cNvSpPr/>
-          <p:nvPr/>
-        </p:nvSpPr>
-        <p:spPr>
+            <a:endParaRPr lang="en-US" sz="2100"/>
+          </a:p>
+        </p:txBody>
+      </p:sp>
+      <p:sp>
+        <p:nvSpPr>
+          <p:cNvPr id="1303609322" name="Text 10"/>
+          <p:cNvSpPr/>
+          <p:nvPr/>
+        </p:nvSpPr>
+        <p:spPr bwMode="auto">
           <a:xfrm>
             <a:off x="8503920" y="3291840"/>
             <a:ext cx="2651760" cy="1280160"/>
@@ -1970,24 +2027,25 @@
           <a:bodyPr wrap="square" lIns="0" tIns="0" rIns="0" bIns="0" rtlCol="0" anchor="t"/>
           <a:lstStyle/>
           <a:p>
-            <a:pPr indent="0" marL="0">
+            <a:pPr marL="0" indent="0">
               <a:lnSpc>
                 <a:spcPts val="2100"/>
               </a:lnSpc>
               <a:buNone/>
-            </a:pPr>
-            <a:r>
-              <a:rPr lang="en-US" sz="1450" dirty="0">
+              <a:defRPr/>
+            </a:pPr>
+            <a:r>
+              <a:rPr lang="en-US" sz="1450">
                 <a:solidFill>
                   <a:srgbClr val="1A1A1A"/>
                 </a:solidFill>
-                <a:latin typeface="Calibri" pitchFamily="34" charset="0"/>
-                <a:ea typeface="Calibri" pitchFamily="34" charset="-122"/>
-                <a:cs typeface="Calibri" pitchFamily="34" charset="-120"/>
+                <a:latin typeface="Calibri"/>
+                <a:ea typeface="Calibri"/>
+                <a:cs typeface="Calibri"/>
               </a:rPr>
               <a:t>Every threshold published, every signal recorded — explainable to a regulator field by field.</a:t>
             </a:r>
-            <a:endParaRPr lang="en-US" sz="1450" dirty="0"/>
+            <a:endParaRPr lang="en-US" sz="1450"/>
           </a:p>
         </p:txBody>
       </p:sp>
@@ -1996,14 +2054,22 @@
   <p:clrMapOvr>
     <a:masterClrMapping/>
   </p:clrMapOvr>
+  <mc:AlternateContent xmlns:mc="http://schemas.openxmlformats.org/markup-compatibility/2006">
+    <mc:Choice xmlns:p159="http://schemas.microsoft.com/office/powerpoint/2015/09/main" xmlns:p14="http://schemas.microsoft.com/office/powerpoint/2010/main" Requires="p159">
+      <p:transition p14:dur="500" advClick="1"/>
+    </mc:Choice>
+    <mc:Fallback>
+      <p:transition advClick="1"/>
+    </mc:Fallback>
+  </mc:AlternateContent>
 </p:sld>
 </file>
 
 <file path=ppt/slides/slide3.xml><?xml version="1.0" encoding="utf-8"?>
-<p:sld xmlns:a="http://schemas.openxmlformats.org/drawingml/2006/main" xmlns:r="http://schemas.openxmlformats.org/officeDocument/2006/relationships" xmlns:p="http://schemas.openxmlformats.org/presentationml/2006/main">
+<p:sld xmlns:a="http://schemas.openxmlformats.org/drawingml/2006/main" xmlns:r="http://schemas.openxmlformats.org/officeDocument/2006/relationships" xmlns:p="http://schemas.openxmlformats.org/presentationml/2006/main" xmlns:m="http://schemas.openxmlformats.org/officeDocument/2006/math" xmlns:w="http://schemas.openxmlformats.org/wordprocessingml/2006/main" xmlns:mc="http://schemas.openxmlformats.org/markup-compatibility/2006" showMasterPhAnim="0" showMasterSp="1" show="1">
   <p:cSld name="Slide 3">
     <p:bg>
-      <p:bgPr>
+      <p:bgPr shadeToTitle="0">
         <a:solidFill>
           <a:srgbClr val="07301F"/>
         </a:solidFill>
@@ -2015,7 +2081,7 @@
         <p:cNvGrpSpPr/>
         <p:nvPr/>
       </p:nvGrpSpPr>
-      <p:grpSpPr>
+      <p:grpSpPr bwMode="auto">
         <a:xfrm>
           <a:off x="0" y="0"/>
           <a:ext cx="0" cy="0"/>
@@ -2025,11 +2091,11 @@
       </p:grpSpPr>
       <p:sp>
         <p:nvSpPr>
-          <p:cNvPr id="2" name="Text 0"/>
-          <p:cNvSpPr/>
-          <p:nvPr/>
-        </p:nvSpPr>
-        <p:spPr>
+          <p:cNvPr id="452402282" name="Text 0"/>
+          <p:cNvSpPr/>
+          <p:nvPr/>
+        </p:nvSpPr>
+        <p:spPr bwMode="auto">
           <a:xfrm>
             <a:off x="822960" y="1691640"/>
             <a:ext cx="10515600" cy="868680"/>
@@ -2044,31 +2110,32 @@
           <a:bodyPr wrap="square" rtlCol="0" anchor="ctr"/>
           <a:lstStyle/>
           <a:p>
-            <a:pPr indent="0" marL="0">
-              <a:buNone/>
-            </a:pPr>
-            <a:r>
-              <a:rPr lang="en-US" sz="5400" b="1" dirty="0">
+            <a:pPr marL="0" indent="0">
+              <a:buNone/>
+              <a:defRPr/>
+            </a:pPr>
+            <a:r>
+              <a:rPr lang="en-US" sz="5400" b="1">
                 <a:solidFill>
                   <a:srgbClr val="FFFFFF"/>
                 </a:solidFill>
-                <a:latin typeface="Cambria" pitchFamily="34" charset="0"/>
-                <a:ea typeface="Cambria" pitchFamily="34" charset="-122"/>
-                <a:cs typeface="Cambria" pitchFamily="34" charset="-120"/>
+                <a:latin typeface="Cambria"/>
+                <a:ea typeface="Cambria"/>
+                <a:cs typeface="Cambria"/>
               </a:rPr>
               <a:t>SecureWealth Twin</a:t>
             </a:r>
-            <a:endParaRPr lang="en-US" sz="5400" dirty="0"/>
-          </a:p>
-        </p:txBody>
-      </p:sp>
-      <p:sp>
-        <p:nvSpPr>
-          <p:cNvPr id="3" name="Text 1"/>
-          <p:cNvSpPr/>
-          <p:nvPr/>
-        </p:nvSpPr>
-        <p:spPr>
+            <a:endParaRPr lang="en-US" sz="5400"/>
+          </a:p>
+        </p:txBody>
+      </p:sp>
+      <p:sp>
+        <p:nvSpPr>
+          <p:cNvPr id="1229643071" name="Text 1"/>
+          <p:cNvSpPr/>
+          <p:nvPr/>
+        </p:nvSpPr>
+        <p:spPr bwMode="auto">
           <a:xfrm>
             <a:off x="868680" y="2606040"/>
             <a:ext cx="10515600" cy="457200"/>
@@ -2083,31 +2150,32 @@
           <a:bodyPr wrap="square" rtlCol="0" anchor="ctr"/>
           <a:lstStyle/>
           <a:p>
-            <a:pPr indent="0" marL="0">
-              <a:buNone/>
-            </a:pPr>
-            <a:r>
-              <a:rPr lang="en-US" sz="2200" i="1" dirty="0">
+            <a:pPr marL="0" indent="0">
+              <a:buNone/>
+              <a:defRPr/>
+            </a:pPr>
+            <a:r>
+              <a:rPr lang="en-US" sz="2200" i="1">
                 <a:solidFill>
                   <a:srgbClr val="C9A227"/>
                 </a:solidFill>
-                <a:latin typeface="Calibri" pitchFamily="34" charset="0"/>
-                <a:ea typeface="Calibri" pitchFamily="34" charset="-122"/>
-                <a:cs typeface="Calibri" pitchFamily="34" charset="-120"/>
+                <a:latin typeface="Calibri"/>
+                <a:ea typeface="Calibri"/>
+                <a:cs typeface="Calibri"/>
               </a:rPr>
               <a:t>Wealth First, Security Always</a:t>
             </a:r>
-            <a:endParaRPr lang="en-US" sz="2200" dirty="0"/>
-          </a:p>
-        </p:txBody>
-      </p:sp>
-      <p:sp>
-        <p:nvSpPr>
-          <p:cNvPr id="4" name="Shape 2"/>
-          <p:cNvSpPr/>
-          <p:nvPr/>
-        </p:nvSpPr>
-        <p:spPr>
+            <a:endParaRPr lang="en-US" sz="2200"/>
+          </a:p>
+        </p:txBody>
+      </p:sp>
+      <p:sp>
+        <p:nvSpPr>
+          <p:cNvPr id="2042182720" name="Shape 2"/>
+          <p:cNvSpPr/>
+          <p:nvPr/>
+        </p:nvSpPr>
+        <p:spPr bwMode="auto">
           <a:xfrm>
             <a:off x="822960" y="3611880"/>
             <a:ext cx="10515600" cy="1051560"/>
@@ -2130,11 +2198,11 @@
       </p:sp>
       <p:sp>
         <p:nvSpPr>
-          <p:cNvPr id="5" name="Text 3"/>
-          <p:cNvSpPr/>
-          <p:nvPr/>
-        </p:nvSpPr>
-        <p:spPr>
+          <p:cNvPr id="2064877359" name="Text 3"/>
+          <p:cNvSpPr/>
+          <p:nvPr/>
+        </p:nvSpPr>
+        <p:spPr bwMode="auto">
           <a:xfrm>
             <a:off x="822960" y="3611880"/>
             <a:ext cx="10515600" cy="1051560"/>
@@ -2149,31 +2217,32 @@
           <a:bodyPr wrap="square" lIns="0" tIns="0" rIns="0" bIns="0" rtlCol="0" anchor="ctr"/>
           <a:lstStyle/>
           <a:p>
-            <a:pPr algn="ctr" indent="0" marL="0">
-              <a:buNone/>
-            </a:pPr>
-            <a:r>
-              <a:rPr lang="en-US" sz="1800" b="1" dirty="0">
+            <a:pPr marL="0" indent="0" algn="ctr">
+              <a:buNone/>
+              <a:defRPr/>
+            </a:pPr>
+            <a:r>
+              <a:rPr lang="en-US" sz="1800" b="1">
                 <a:solidFill>
                   <a:srgbClr val="FFFFFF"/>
                 </a:solidFill>
-                <a:latin typeface="Calibri" pitchFamily="34" charset="0"/>
-                <a:ea typeface="Calibri" pitchFamily="34" charset="-122"/>
-                <a:cs typeface="Calibri" pitchFamily="34" charset="-120"/>
-              </a:rPr>
-              <a:t>Team [TEAM NAME]   ·   Swayam  ·  Mahak  ·  Archit  ·  Ayush  ·  Vishwas  ·  Aayat</a:t>
-            </a:r>
-            <a:endParaRPr lang="en-US" sz="1800" dirty="0"/>
-          </a:p>
-        </p:txBody>
-      </p:sp>
-      <p:sp>
-        <p:nvSpPr>
-          <p:cNvPr id="6" name="Text 4"/>
-          <p:cNvSpPr/>
-          <p:nvPr/>
-        </p:nvSpPr>
-        <p:spPr>
+                <a:latin typeface="Calibri"/>
+                <a:ea typeface="Calibri"/>
+                <a:cs typeface="Calibri"/>
+              </a:rPr>
+              <a:t>Team AMAVAS   ·   Swayam  ·  Mahak  ·  Archit  ·  Ayush  ·  Vishwas  ·  Aayat</a:t>
+            </a:r>
+            <a:endParaRPr lang="en-US" sz="1800"/>
+          </a:p>
+        </p:txBody>
+      </p:sp>
+      <p:sp>
+        <p:nvSpPr>
+          <p:cNvPr id="46007486" name="Text 4"/>
+          <p:cNvSpPr/>
+          <p:nvPr/>
+        </p:nvSpPr>
+        <p:spPr bwMode="auto">
           <a:xfrm>
             <a:off x="822960" y="5029200"/>
             <a:ext cx="10515600" cy="457200"/>
@@ -2188,21 +2257,22 @@
           <a:bodyPr wrap="square" rtlCol="0" anchor="ctr"/>
           <a:lstStyle/>
           <a:p>
-            <a:pPr algn="ctr" indent="0" marL="0">
-              <a:buNone/>
-            </a:pPr>
-            <a:r>
-              <a:rPr lang="en-US" sz="1700" i="1" dirty="0">
+            <a:pPr marL="0" indent="0" algn="ctr">
+              <a:buNone/>
+              <a:defRPr/>
+            </a:pPr>
+            <a:r>
+              <a:rPr lang="en-US" sz="1700" i="1">
                 <a:solidFill>
                   <a:srgbClr val="C9D6CE"/>
                 </a:solidFill>
-                <a:latin typeface="Calibri" pitchFamily="34" charset="0"/>
-                <a:ea typeface="Calibri" pitchFamily="34" charset="-122"/>
-                <a:cs typeface="Calibri" pitchFamily="34" charset="-120"/>
+                <a:latin typeface="Calibri"/>
+                <a:ea typeface="Calibri"/>
+                <a:cs typeface="Calibri"/>
               </a:rPr>
               <a:t>Thank you</a:t>
             </a:r>
-            <a:endParaRPr lang="en-US" sz="1700" dirty="0"/>
+            <a:endParaRPr lang="en-US" sz="1700"/>
           </a:p>
         </p:txBody>
       </p:sp>
@@ -2211,11 +2281,19 @@
   <p:clrMapOvr>
     <a:masterClrMapping/>
   </p:clrMapOvr>
+  <mc:AlternateContent xmlns:mc="http://schemas.openxmlformats.org/markup-compatibility/2006">
+    <mc:Choice xmlns:p159="http://schemas.microsoft.com/office/powerpoint/2015/09/main" xmlns:p14="http://schemas.microsoft.com/office/powerpoint/2010/main" Requires="p159">
+      <p:transition p14:dur="500" advClick="1"/>
+    </mc:Choice>
+    <mc:Fallback>
+      <p:transition advClick="1"/>
+    </mc:Fallback>
+  </mc:AlternateContent>
 </p:sld>
 </file>
 
 <file path=ppt/theme/theme1.xml><?xml version="1.0" encoding="utf-8"?>
-<a:theme xmlns:a="http://schemas.openxmlformats.org/drawingml/2006/main" name="Office Theme">
+<a:theme xmlns:a="http://schemas.openxmlformats.org/drawingml/2006/main" xmlns:r="http://schemas.openxmlformats.org/officeDocument/2006/relationships" xmlns:p="http://schemas.openxmlformats.org/presentationml/2006/main" name="Office Theme">
   <a:themeElements>
     <a:clrScheme name="Office">
       <a:dk1>
@@ -2257,108 +2335,14 @@
     </a:clrScheme>
     <a:fontScheme name="Office">
       <a:majorFont>
-        <a:latin typeface="Calibri Light" panose="020F0302020204030204"/>
-        <a:ea typeface=""/>
-        <a:cs typeface=""/>
-        <a:font script="Jpan" typeface="游ゴシック Light"/>
-        <a:font script="Hang" typeface="맑은 고딕"/>
-        <a:font script="Hans" typeface="等线 Light"/>
-        <a:font script="Hant" typeface="新細明體"/>
-        <a:font script="Arab" typeface="Times New Roman"/>
-        <a:font script="Hebr" typeface="Times New Roman"/>
-        <a:font script="Thai" typeface="Angsana New"/>
-        <a:font script="Ethi" typeface="Nyala"/>
-        <a:font script="Beng" typeface="Vrinda"/>
-        <a:font script="Gujr" typeface="Shruti"/>
-        <a:font script="Khmr" typeface="MoolBoran"/>
-        <a:font script="Knda" typeface="Tunga"/>
-        <a:font script="Guru" typeface="Raavi"/>
-        <a:font script="Cans" typeface="Euphemia"/>
-        <a:font script="Cher" typeface="Plantagenet Cherokee"/>
-        <a:font script="Yiii" typeface="Microsoft Yi Baiti"/>
-        <a:font script="Tibt" typeface="Microsoft Himalaya"/>
-        <a:font script="Thaa" typeface="MV Boli"/>
-        <a:font script="Deva" typeface="Mangal"/>
-        <a:font script="Telu" typeface="Gautami"/>
-        <a:font script="Taml" typeface="Latha"/>
-        <a:font script="Syrc" typeface="Estrangelo Edessa"/>
-        <a:font script="Orya" typeface="Kalinga"/>
-        <a:font script="Mlym" typeface="Kartika"/>
-        <a:font script="Laoo" typeface="DokChampa"/>
-        <a:font script="Sinh" typeface="Iskoola Pota"/>
-        <a:font script="Mong" typeface="Mongolian Baiti"/>
-        <a:font script="Viet" typeface="Times New Roman"/>
-        <a:font script="Uigh" typeface="Microsoft Uighur"/>
-        <a:font script="Geor" typeface="Sylfaen"/>
-        <a:font script="Armn" typeface="Arial"/>
-        <a:font script="Bugi" typeface="Leelawadee UI"/>
-        <a:font script="Bopo" typeface="Microsoft JhengHei"/>
-        <a:font script="Java" typeface="Javanese Text"/>
-        <a:font script="Lisu" typeface="Segoe UI"/>
-        <a:font script="Mymr" typeface="Myanmar Text"/>
-        <a:font script="Nkoo" typeface="Ebrima"/>
-        <a:font script="Olck" typeface="Nirmala UI"/>
-        <a:font script="Osma" typeface="Ebrima"/>
-        <a:font script="Phag" typeface="Phagspa"/>
-        <a:font script="Syrn" typeface="Estrangelo Edessa"/>
-        <a:font script="Syrj" typeface="Estrangelo Edessa"/>
-        <a:font script="Syre" typeface="Estrangelo Edessa"/>
-        <a:font script="Sora" typeface="Nirmala UI"/>
-        <a:font script="Tale" typeface="Microsoft Tai Le"/>
-        <a:font script="Talu" typeface="Microsoft New Tai Lue"/>
-        <a:font script="Tfng" typeface="Ebrima"/>
+        <a:latin typeface="Calibri Light"/>
+        <a:ea typeface="Arial"/>
+        <a:cs typeface="Arial"/>
       </a:majorFont>
       <a:minorFont>
-        <a:latin typeface="Calibri" panose="020F0502020204030204"/>
-        <a:ea typeface=""/>
-        <a:cs typeface=""/>
-        <a:font script="Jpan" typeface="游ゴシック"/>
-        <a:font script="Hang" typeface="맑은 고딕"/>
-        <a:font script="Hans" typeface="等线"/>
-        <a:font script="Hant" typeface="新細明體"/>
-        <a:font script="Arab" typeface="Arial"/>
-        <a:font script="Hebr" typeface="Arial"/>
-        <a:font script="Thai" typeface="Cordia New"/>
-        <a:font script="Ethi" typeface="Nyala"/>
-        <a:font script="Beng" typeface="Vrinda"/>
-        <a:font script="Gujr" typeface="Shruti"/>
-        <a:font script="Khmr" typeface="DaunPenh"/>
-        <a:font script="Knda" typeface="Tunga"/>
-        <a:font script="Guru" typeface="Raavi"/>
-        <a:font script="Cans" typeface="Euphemia"/>
-        <a:font script="Cher" typeface="Plantagenet Cherokee"/>
-        <a:font script="Yiii" typeface="Microsoft Yi Baiti"/>
-        <a:font script="Tibt" typeface="Microsoft Himalaya"/>
-        <a:font script="Thaa" typeface="MV Boli"/>
-        <a:font script="Deva" typeface="Mangal"/>
-        <a:font script="Telu" typeface="Gautami"/>
-        <a:font script="Taml" typeface="Latha"/>
-        <a:font script="Syrc" typeface="Estrangelo Edessa"/>
-        <a:font script="Orya" typeface="Kalinga"/>
-        <a:font script="Mlym" typeface="Kartika"/>
-        <a:font script="Laoo" typeface="DokChampa"/>
-        <a:font script="Sinh" typeface="Iskoola Pota"/>
-        <a:font script="Mong" typeface="Mongolian Baiti"/>
-        <a:font script="Viet" typeface="Arial"/>
-        <a:font script="Uigh" typeface="Microsoft Uighur"/>
-        <a:font script="Geor" typeface="Sylfaen"/>
-        <a:font script="Armn" typeface="Arial"/>
-        <a:font script="Bugi" typeface="Leelawadee UI"/>
-        <a:font script="Bopo" typeface="Microsoft JhengHei"/>
-        <a:font script="Java" typeface="Javanese Text"/>
-        <a:font script="Lisu" typeface="Segoe UI"/>
-        <a:font script="Mymr" typeface="Myanmar Text"/>
-        <a:font script="Nkoo" typeface="Ebrima"/>
-        <a:font script="Olck" typeface="Nirmala UI"/>
-        <a:font script="Osma" typeface="Ebrima"/>
-        <a:font script="Phag" typeface="Phagspa"/>
-        <a:font script="Syrn" typeface="Estrangelo Edessa"/>
-        <a:font script="Syrj" typeface="Estrangelo Edessa"/>
-        <a:font script="Syre" typeface="Estrangelo Edessa"/>
-        <a:font script="Sora" typeface="Nirmala UI"/>
-        <a:font script="Tale" typeface="Microsoft Tai Le"/>
-        <a:font script="Talu" typeface="Microsoft New Tai Lue"/>
-        <a:font script="Tfng" typeface="Ebrima"/>
+        <a:latin typeface="Calibri"/>
+        <a:ea typeface="Arial"/>
+        <a:cs typeface="Arial"/>
       </a:minorFont>
     </a:fontScheme>
     <a:fmtScheme name="Office">
@@ -2366,7 +2350,7 @@
         <a:solidFill>
           <a:schemeClr val="phClr"/>
         </a:solidFill>
-        <a:gradFill rotWithShape="1">
+        <a:gradFill>
           <a:gsLst>
             <a:gs pos="0">
               <a:schemeClr val="phClr">
@@ -2392,7 +2376,7 @@
           </a:gsLst>
           <a:lin ang="5400000" scaled="0"/>
         </a:gradFill>
-        <a:gradFill rotWithShape="1">
+        <a:gradFill>
           <a:gsLst>
             <a:gs pos="0">
               <a:schemeClr val="phClr">
@@ -2469,7 +2453,7 @@
             <a:satMod val="170000"/>
           </a:schemeClr>
         </a:solidFill>
-        <a:gradFill rotWithShape="1">
+        <a:gradFill>
           <a:gsLst>
             <a:gs pos="0">
               <a:schemeClr val="phClr">
@@ -2500,11 +2484,5 @@
     </a:fmtScheme>
   </a:themeElements>
   <a:objectDefaults/>
-  <a:extraClrSchemeLst/>
-  <a:extLst>
-    <a:ext uri="{05A4C25C-085E-4340-85A3-A5531E510DB2}">
-      <thm15:themeFamily xmlns:thm15="http://schemas.microsoft.com/office/thememl/2012/main" name="Office Theme" id="{62F939B6-93AF-4DB8-9C6B-D6C7DFDC589F}" vid="{4A3C46E8-61CC-4603-A589-7422A47A8E4A}"/>
-    </a:ext>
-  </a:extLst>
 </a:theme>
 </file>
</xml_diff>